<commit_message>
docs/pptx: 仓库正式定名『星链赚大矿』star-chain-earn-mine，同步 PUBLISHING 与 PPT 末页
</commit_message>
<xml_diff>
--- a/pptx/宇宙挖矿机器人/宇宙挖矿机器人.pptx
+++ b/pptx/宇宙挖矿机器人/宇宙挖矿机器人.pptx
@@ -6066,7 +6066,7 @@
   <p:cSld>
     <p:spTree>
       <p:nvGrpSpPr>
-        <p:cNvPr id="68" name="" descr="&lt;Slide type=&quot;ending&quot;&gt;&#10;  &lt;Box style={{ width: '100%', height: '100%', background: '#0B1120', justifyContent: 'center', alignItems: 'center', padding: '0 80px' }}&gt;&#10;    &lt;Animation animType=&quot;fadeIn&quot; duration={700}&gt;&#10;      &lt;Text style={{ fontSize: 46, color: '#E5EDF7', fontWeight: 'bold', textAlign: 'center', lineHeight: 1.25 }}&gt;一台扫地机器人，&lt;Text style={{ color: '#22D3EE' }}&gt;一条通往宇宙采矿的技术闭环&lt;/Text&gt;&lt;/Text&gt;&#10;    &lt;/Animation&gt;&#10;    &lt;Animation animType=&quot;fadeIn&quot; startType=&quot;afterPrevious&quot; duration={700}&gt;&#10;      &lt;Box style={{ background: '#0F1B33', border: '1px solid #1E3A5F', borderRadius: 14, padding: '28px 40px', marginTop: 36, alignItems: 'center' }}&gt;&#10;        &lt;Text style={{ fontSize: 22, color: '#3B82F6', fontWeight: 'bold' }}&gt;github.com/yydemo/cosmic-mining-robot&lt;/Text&gt;&#10;        &lt;Text style={{ fontSize: 16, color: '#94A3B8', marginTop: 12, textAlign: 'center', lineHeight: 1.7 }}&gt;含仿真内核 / 结构图 / 区块链 / 星链 / 改装蓝图&lt;Text style={{ color: '#94A3B8' }}&gt;&lt;br/&gt;&lt;/Text&gt;欢迎 Star · Fork · 共建&lt;/Text&gt;&#10;      &lt;/Box&gt;&#10;    &lt;/Animation&gt;&#10;    &lt;Animation animType=&quot;fadeIn&quot; startType=&quot;afterPrevious&quot; duration={700}&gt;&#10;      &lt;Text style={{ fontSize: 16, color: '#64748B', marginTop: 30 }}&gt;CMR Team · 2026 · 已开源&lt;/Text&gt;&#10;    &lt;/Animation&gt;&#10;  &lt;/Box&gt;&#10;&lt;/Slide&gt;&#10;"/>
+        <p:cNvPr id="68" name="" descr="&lt;Slide type=&quot;ending&quot;&gt;&#10;  &lt;Box style={{ width: '100%', height: '100%', background: '#0B1120', justifyContent: 'center', alignItems: 'center', padding: '0 80px' }}&gt;&#10;    &lt;Animation animType=&quot;fadeIn&quot; duration={700}&gt;&#10;      &lt;Text style={{ fontSize: 46, color: '#E5EDF7', fontWeight: 'bold', textAlign: 'center', lineHeight: 1.25 }}&gt;一台扫地机器人，&lt;Text style={{ color: '#22D3EE' }}&gt;一条通往宇宙采矿的技术闭环&lt;/Text&gt;&lt;/Text&gt;&#10;    &lt;/Animation&gt;&#10;    &lt;Animation animType=&quot;fadeIn&quot; startType=&quot;afterPrevious&quot; duration={700}&gt;&#10;      &lt;Box style={{ background: '#0F1B33', border: '1px solid #1E3A5F', borderRadius: 14, padding: '28px 40px', marginTop: 36, alignItems: 'center' }}&gt;&#10;        &lt;Text style={{ fontSize: 22, color: '#3B82F6', fontWeight: 'bold' }}&gt;github.com/yydemo/star-chain-earn-mine&lt;/Text&gt;&#10;        &lt;Text style={{ fontSize: 15, color: '#94A3B8', marginTop: 8 }}&gt;星链赚大矿 · 宇宙挖矿机器人&lt;/Text&gt;&#10;        &lt;Text style={{ fontSize: 16, color: '#94A3B8', marginTop: 12, textAlign: 'center', lineHeight: 1.7 }}&gt;含仿真内核 / 结构图 / 区块链 / 星链 / 改装蓝图&lt;Text style={{ color: '#94A3B8' }}&gt;&lt;br/&gt;&lt;/Text&gt;欢迎 Star · Fork · 共建&lt;/Text&gt;&#10;      &lt;/Box&gt;&#10;    &lt;/Animation&gt;&#10;    &lt;Animation animType=&quot;fadeIn&quot; startType=&quot;afterPrevious&quot; duration={700}&gt;&#10;      &lt;Text style={{ fontSize: 16, color: '#64748B', marginTop: 30 }}&gt;CMR Team · 2026 · 已开源&lt;/Text&gt;&#10;    &lt;/Animation&gt;&#10;  &lt;/Box&gt;&#10;&lt;/Slide&gt;&#10;"/>
         <p:cNvGrpSpPr/>
         <p:nvPr/>
       </p:nvGrpSpPr>
@@ -6110,7 +6110,7 @@
         </p:nvSpPr>
         <p:spPr>
           <a:xfrm rot="0" flipH="0" flipV="0">
-            <a:off x="1495425" y="1924050"/>
+            <a:off x="1495425" y="1800225"/>
             <a:ext cx="9201150" cy="657225"/>
           </a:xfrm>
           <a:prstGeom prst="rect"/>
@@ -6155,12 +6155,12 @@
         </p:nvSpPr>
         <p:spPr>
           <a:xfrm rot="0" flipH="0" flipV="0">
-            <a:off x="3467100" y="2924175"/>
-            <a:ext cx="5257800" cy="1533525"/>
+            <a:off x="3476625" y="2800350"/>
+            <a:ext cx="5238750" cy="1781175"/>
           </a:xfrm>
           <a:prstGeom prst="roundRect">
             <a:avLst>
-              <a:gd name="adj" fmla="val 8696"/>
+              <a:gd name="adj" fmla="val 7487"/>
             </a:avLst>
           </a:prstGeom>
           <a:solidFill>
@@ -6186,8 +6186,8 @@
         </p:nvSpPr>
         <p:spPr>
           <a:xfrm rot="0" flipH="0" flipV="0">
-            <a:off x="3848100" y="3190875"/>
-            <a:ext cx="4495800" cy="257175"/>
+            <a:off x="3857625" y="3067050"/>
+            <a:ext cx="4476750" cy="257175"/>
           </a:xfrm>
           <a:prstGeom prst="rect"/>
         </p:spPr>
@@ -6207,7 +6207,7 @@
                 <a:latin typeface="Microsoft YaHei"/>
                 <a:ea typeface="Microsoft YaHei"/>
               </a:rPr>
-              <a:t>github.com/yydemo/cosmic-mining-robot</a:t>
+              <a:t>github.com/yydemo/star-chain-earn-mine</a:t>
             </a:r>
             <a:endParaRPr/>
           </a:p>
@@ -6221,7 +6221,62 @@
         </p:nvSpPr>
         <p:spPr>
           <a:xfrm rot="0" flipH="0" flipV="0">
-            <a:off x="4486275" y="3562350"/>
+            <a:off x="5181600" y="3400425"/>
+            <a:ext cx="1838325" cy="171450"/>
+          </a:xfrm>
+          <a:prstGeom prst="rect"/>
+        </p:spPr>
+        <p:txBody>
+          <a:bodyPr wrap="none" lIns="0" tIns="0" rIns="0" bIns="0"/>
+          <a:p>
+            <a:pPr>
+              <a:lnSpc>
+                <a:spcPct val="100000"/>
+              </a:lnSpc>
+            </a:pPr>
+            <a:r>
+              <a:rPr lang="zh-CN" sz="1125">
+                <a:solidFill>
+                  <a:srgbClr val="94A3B8"/>
+                </a:solidFill>
+                <a:latin typeface="Microsoft YaHei"/>
+                <a:ea typeface="Microsoft YaHei"/>
+              </a:rPr>
+              <a:t>星链赚大矿</a:t>
+            </a:r>
+            <a:r>
+              <a:rPr lang="en-US" sz="1125">
+                <a:solidFill>
+                  <a:srgbClr val="94A3B8"/>
+                </a:solidFill>
+                <a:latin typeface="Microsoft YaHei"/>
+                <a:ea typeface="Microsoft YaHei"/>
+              </a:rPr>
+              <a:t xml:space="preserve"> · </a:t>
+            </a:r>
+            <a:r>
+              <a:rPr lang="zh-CN" sz="1125">
+                <a:solidFill>
+                  <a:srgbClr val="94A3B8"/>
+                </a:solidFill>
+                <a:latin typeface="Microsoft YaHei"/>
+                <a:ea typeface="Microsoft YaHei"/>
+              </a:rPr>
+              <a:t>宇宙挖矿机器人</a:t>
+            </a:r>
+            <a:endParaRPr/>
+          </a:p>
+        </p:txBody>
+      </p:sp>
+      <p:sp>
+        <p:nvSpPr>
+          <p:cNvPr id="74" name="" descr="{&quot;isTemplate&quot;:true,&quot;type&quot;:&quot;text&quot;}"/>
+          <p:cNvSpPr txBox="1"/>
+          <p:nvPr/>
+        </p:nvSpPr>
+        <p:spPr>
+          <a:xfrm rot="0" flipH="0" flipV="0">
+            <a:off x="4486275" y="3686175"/>
             <a:ext cx="3219450" cy="628650"/>
           </a:xfrm>
           <a:prstGeom prst="rect"/>
@@ -6368,13 +6423,13 @@
       </p:sp>
       <p:sp>
         <p:nvSpPr>
-          <p:cNvPr id="74" name="" descr="{&quot;isTemplate&quot;:true,&quot;type&quot;:&quot;text&quot;}"/>
+          <p:cNvPr id="75" name="" descr="{&quot;isTemplate&quot;:true,&quot;type&quot;:&quot;text&quot;}"/>
           <p:cNvSpPr txBox="1"/>
           <p:nvPr/>
         </p:nvSpPr>
         <p:spPr>
           <a:xfrm rot="0" flipH="0" flipV="0">
-            <a:off x="5172075" y="4743450"/>
+            <a:off x="5172075" y="4867275"/>
             <a:ext cx="1847850" cy="190500"/>
           </a:xfrm>
           <a:prstGeom prst="rect"/>
@@ -6538,17 +6593,8 @@
                                   </p:childTnLst>
                                 </p:cTn>
                               </p:par>
-                            </p:childTnLst>
-                          </p:cTn>
-                        </p:par>
-                        <p:par>
-                          <p:cTn fill="hold">
-                            <p:stCondLst>
-                              <p:cond delay="700"/>
-                            </p:stCondLst>
-                            <p:childTnLst>
                               <p:par>
-                                <p:cTn id="142" presetID="10" presetClass="entr" presetSubtype="0" fill="hold" grpId="1" nodeType="afterEffect">
+                                <p:cTn id="142" presetID="10" presetClass="entr" presetSubtype="0" fill="hold" grpId="1" nodeType="withEffect">
                                   <p:stCondLst>
                                     <p:cond delay="0"/>
                                   </p:stCondLst>
@@ -6561,7 +6607,7 @@
                                           </p:stCondLst>
                                         </p:cTn>
                                         <p:tgtEl>
-                                          <p:spTgt spid="71"/>
+                                          <p:spTgt spid="74"/>
                                         </p:tgtEl>
                                         <p:attrNameLst>
                                           <p:attrName>style.visibility</p:attrName>
@@ -6575,7 +6621,7 @@
                                       <p:cBhvr>
                                         <p:cTn id="144" dur="700"/>
                                         <p:tgtEl>
-                                          <p:spTgt spid="71"/>
+                                          <p:spTgt spid="74"/>
                                         </p:tgtEl>
                                       </p:cBhvr>
                                     </p:animEffect>
@@ -6592,7 +6638,7 @@
                             </p:stCondLst>
                             <p:childTnLst>
                               <p:par>
-                                <p:cTn id="145" presetID="10" presetClass="entr" presetSubtype="0" fill="hold" grpId="2" nodeType="afterEffect">
+                                <p:cTn id="145" presetID="10" presetClass="entr" presetSubtype="0" fill="hold" grpId="1" nodeType="afterEffect">
                                   <p:stCondLst>
                                     <p:cond delay="0"/>
                                   </p:stCondLst>
@@ -6605,7 +6651,7 @@
                                           </p:stCondLst>
                                         </p:cTn>
                                         <p:tgtEl>
-                                          <p:spTgt spid="74"/>
+                                          <p:spTgt spid="71"/>
                                         </p:tgtEl>
                                         <p:attrNameLst>
                                           <p:attrName>style.visibility</p:attrName>
@@ -6619,7 +6665,51 @@
                                       <p:cBhvr>
                                         <p:cTn id="147" dur="700"/>
                                         <p:tgtEl>
-                                          <p:spTgt spid="74"/>
+                                          <p:spTgt spid="71"/>
+                                        </p:tgtEl>
+                                      </p:cBhvr>
+                                    </p:animEffect>
+                                  </p:childTnLst>
+                                </p:cTn>
+                              </p:par>
+                            </p:childTnLst>
+                          </p:cTn>
+                        </p:par>
+                        <p:par>
+                          <p:cTn fill="hold">
+                            <p:stCondLst>
+                              <p:cond delay="700"/>
+                            </p:stCondLst>
+                            <p:childTnLst>
+                              <p:par>
+                                <p:cTn id="148" presetID="10" presetClass="entr" presetSubtype="0" fill="hold" grpId="2" nodeType="afterEffect">
+                                  <p:stCondLst>
+                                    <p:cond delay="0"/>
+                                  </p:stCondLst>
+                                  <p:childTnLst>
+                                    <p:set>
+                                      <p:cBhvr>
+                                        <p:cTn id="149" dur="1" fill="hold">
+                                          <p:stCondLst>
+                                            <p:cond delay="0"/>
+                                          </p:stCondLst>
+                                        </p:cTn>
+                                        <p:tgtEl>
+                                          <p:spTgt spid="75"/>
+                                        </p:tgtEl>
+                                        <p:attrNameLst>
+                                          <p:attrName>style.visibility</p:attrName>
+                                        </p:attrNameLst>
+                                      </p:cBhvr>
+                                      <p:to>
+                                        <p:strVal val="visible"/>
+                                      </p:to>
+                                    </p:set>
+                                    <p:animEffect transition="in" filter="fade">
+                                      <p:cBhvr>
+                                        <p:cTn id="150" dur="700"/>
+                                        <p:tgtEl>
+                                          <p:spTgt spid="75"/>
                                         </p:tgtEl>
                                       </p:cBhvr>
                                     </p:animEffect>
@@ -6658,7 +6748,7 @@
   <p:cSld>
     <p:spTree>
       <p:nvGrpSpPr>
-        <p:cNvPr id="75" name="" descr="&lt;Slide type=&quot;catalog&quot;&gt;&#10;  &lt;Box style={{ width: '100%', height: '100%', background: '#0B1120', flexDirection: 'row' }}&gt;&#10;    &lt;Box style={{ width: '33%', justifyContent: 'center', padding: '0 52px', background: '#0F1B33' }}&gt;&#10;      &lt;Text style={{ fontSize: 46, color: '#E5EDF7', fontWeight: 'bold', lineHeight: 1.1 }}&gt;目录&lt;Text style={{ color: '#22D3EE' }}&gt;&lt;br/&gt;CONTENTS&lt;/Text&gt;&lt;/Text&gt;&#10;      &lt;Text style={{ fontSize: 16, color: '#94A3B8', marginTop: 24, lineHeight: 1.6 }}&gt;从家用清扫到地外采矿&lt;br/&gt;的完整技术闭环&lt;/Text&gt;&#10;    &lt;/Box&gt;&#10;    &lt;Box style={{ flex: 1, justifyContent: 'center', padding: '0 56px', gap: 26 }}&gt;&#10;      &lt;Animation animType=&quot;fadeIn&quot; duration={600}&gt;&#10;        &lt;Box style={{ flexDirection: 'row', gap: 20, alignItems: 'center' }}&gt;&#10;          &lt;Text style={{ fontSize: 36, color: '#3B82F6', fontWeight: 'bold' }}&gt;01&lt;/Text&gt;&#10;          &lt;Box&gt;&lt;Text style={{ fontSize: 24, color: '#E5EDF7', fontWeight: 'bold' }}&gt;项目总览&lt;/Text&gt;&lt;Text style={{ fontSize: 15, color: '#94A3B8' }}&gt;系统整体架构 · 改装逻辑&lt;/Text&gt;&lt;/Box&gt;&#10;        &lt;/Box&gt;&#10;      &lt;/Animation&gt;&#10;      &lt;Animation animType=&quot;fadeIn&quot; startType=&quot;afterPrevious&quot; duration={600}&gt;&#10;        &lt;Box style={{ flexDirection: 'row', gap: 20, alignItems: 'center' }}&gt;&#10;          &lt;Text style={{ fontSize: 36, color: '#22D3EE', fontWeight: 'bold' }}&gt;02&lt;/Text&gt;&#10;          &lt;Box&gt;&lt;Text style={{ fontSize: 24, color: '#E5EDF7', fontWeight: 'bold' }}&gt;机器结构与抗辐射芯片&lt;/Text&gt;&lt;Text style={{ fontSize: 15, color: '#94A3B8' }}&gt;扫地机器人底座 · 改装结构 · 西电三代半&lt;/Text&gt;&lt;/Box&gt;&#10;        &lt;/Box&gt;&#10;      &lt;/Animation&gt;&#10;      &lt;Animation animType=&quot;fadeIn&quot; startType=&quot;afterPrevious&quot; duration={600}&gt;&#10;        &lt;Box style={{ flexDirection: 'row', gap: 20, alignItems: 'center' }}&gt;&#10;          &lt;Text style={{ fontSize: 36, color: '#F59E0B', fontWeight: 'bold' }}&gt;03&lt;/Text&gt;&#10;          &lt;Box&gt;&lt;Text style={{ fontSize: 24, color: '#E5EDF7', fontWeight: 'bold' }}&gt;通讯与数据闭环&lt;/Text&gt;&lt;Text style={{ fontSize: 15, color: '#94A3B8' }}&gt;近地轨道 Starlink · 集尘盒区块链售卖&lt;/Text&gt;&lt;/Box&gt;&#10;        &lt;/Box&gt;&#10;      &lt;/Animation&gt;&#10;      &lt;Animation animType=&quot;fadeIn&quot; startType=&quot;afterPrevious&quot; duration={600}&gt;&#10;        &lt;Box style={{ flexDirection: 'row', gap: 20, alignItems: 'center' }}&gt;&#10;          &lt;Text style={{ fontSize: 36, color: '#94A3B8', fontWeight: 'bold' }}&gt;04&lt;/Text&gt;&#10;          &lt;Box&gt;&lt;Text style={{ fontSize: 24, color: '#E5EDF7', fontWeight: 'bold' }}&gt;仿真验证与展望&lt;/Text&gt;&lt;Text style={{ fontSize: 15, color: '#94A3B8' }}&gt;三场景演示结果 · GitHub 发布&lt;/Text&gt;&lt;/Box&gt;&#10;        &lt;/Box&gt;&#10;      &lt;/Animation&gt;&#10;    &lt;/Box&gt;&#10;  &lt;/Box&gt;&#10;&lt;/Slide&gt;&#10;"/>
+        <p:cNvPr id="76" name="" descr="&lt;Slide type=&quot;catalog&quot;&gt;&#10;  &lt;Box style={{ width: '100%', height: '100%', background: '#0B1120', flexDirection: 'row' }}&gt;&#10;    &lt;Box style={{ width: '33%', justifyContent: 'center', padding: '0 52px', background: '#0F1B33' }}&gt;&#10;      &lt;Text style={{ fontSize: 46, color: '#E5EDF7', fontWeight: 'bold', lineHeight: 1.1 }}&gt;目录&lt;Text style={{ color: '#22D3EE' }}&gt;&lt;br/&gt;CONTENTS&lt;/Text&gt;&lt;/Text&gt;&#10;      &lt;Text style={{ fontSize: 16, color: '#94A3B8', marginTop: 24, lineHeight: 1.6 }}&gt;从家用清扫到地外采矿&lt;br/&gt;的完整技术闭环&lt;/Text&gt;&#10;    &lt;/Box&gt;&#10;    &lt;Box style={{ flex: 1, justifyContent: 'center', padding: '0 56px', gap: 26 }}&gt;&#10;      &lt;Animation animType=&quot;fadeIn&quot; duration={600}&gt;&#10;        &lt;Box style={{ flexDirection: 'row', gap: 20, alignItems: 'center' }}&gt;&#10;          &lt;Text style={{ fontSize: 36, color: '#3B82F6', fontWeight: 'bold' }}&gt;01&lt;/Text&gt;&#10;          &lt;Box&gt;&lt;Text style={{ fontSize: 24, color: '#E5EDF7', fontWeight: 'bold' }}&gt;项目总览&lt;/Text&gt;&lt;Text style={{ fontSize: 15, color: '#94A3B8' }}&gt;系统整体架构 · 改装逻辑&lt;/Text&gt;&lt;/Box&gt;&#10;        &lt;/Box&gt;&#10;      &lt;/Animation&gt;&#10;      &lt;Animation animType=&quot;fadeIn&quot; startType=&quot;afterPrevious&quot; duration={600}&gt;&#10;        &lt;Box style={{ flexDirection: 'row', gap: 20, alignItems: 'center' }}&gt;&#10;          &lt;Text style={{ fontSize: 36, color: '#22D3EE', fontWeight: 'bold' }}&gt;02&lt;/Text&gt;&#10;          &lt;Box&gt;&lt;Text style={{ fontSize: 24, color: '#E5EDF7', fontWeight: 'bold' }}&gt;机器结构与抗辐射芯片&lt;/Text&gt;&lt;Text style={{ fontSize: 15, color: '#94A3B8' }}&gt;扫地机器人底座 · 改装结构 · 西电三代半&lt;/Text&gt;&lt;/Box&gt;&#10;        &lt;/Box&gt;&#10;      &lt;/Animation&gt;&#10;      &lt;Animation animType=&quot;fadeIn&quot; startType=&quot;afterPrevious&quot; duration={600}&gt;&#10;        &lt;Box style={{ flexDirection: 'row', gap: 20, alignItems: 'center' }}&gt;&#10;          &lt;Text style={{ fontSize: 36, color: '#F59E0B', fontWeight: 'bold' }}&gt;03&lt;/Text&gt;&#10;          &lt;Box&gt;&lt;Text style={{ fontSize: 24, color: '#E5EDF7', fontWeight: 'bold' }}&gt;通讯与数据闭环&lt;/Text&gt;&lt;Text style={{ fontSize: 15, color: '#94A3B8' }}&gt;近地轨道 Starlink · 集尘盒区块链售卖&lt;/Text&gt;&lt;/Box&gt;&#10;        &lt;/Box&gt;&#10;      &lt;/Animation&gt;&#10;      &lt;Animation animType=&quot;fadeIn&quot; startType=&quot;afterPrevious&quot; duration={600}&gt;&#10;        &lt;Box style={{ flexDirection: 'row', gap: 20, alignItems: 'center' }}&gt;&#10;          &lt;Text style={{ fontSize: 36, color: '#94A3B8', fontWeight: 'bold' }}&gt;04&lt;/Text&gt;&#10;          &lt;Box&gt;&lt;Text style={{ fontSize: 24, color: '#E5EDF7', fontWeight: 'bold' }}&gt;仿真验证与展望&lt;/Text&gt;&lt;Text style={{ fontSize: 15, color: '#94A3B8' }}&gt;三场景演示结果 · GitHub 发布&lt;/Text&gt;&lt;/Box&gt;&#10;        &lt;/Box&gt;&#10;      &lt;/Animation&gt;&#10;    &lt;/Box&gt;&#10;  &lt;/Box&gt;&#10;&lt;/Slide&gt;&#10;"/>
         <p:cNvGrpSpPr/>
         <p:nvPr/>
       </p:nvGrpSpPr>
@@ -6672,7 +6762,7 @@
       </p:grpSpPr>
       <p:sp>
         <p:nvSpPr>
-          <p:cNvPr id="76" name=""/>
+          <p:cNvPr id="77" name=""/>
           <p:cNvSpPr/>
           <p:nvPr/>
         </p:nvSpPr>
@@ -6696,7 +6786,7 @@
       </p:sp>
       <p:sp>
         <p:nvSpPr>
-          <p:cNvPr id="77" name=""/>
+          <p:cNvPr id="78" name=""/>
           <p:cNvSpPr/>
           <p:nvPr/>
         </p:nvSpPr>
@@ -6720,7 +6810,7 @@
       </p:sp>
       <p:sp>
         <p:nvSpPr>
-          <p:cNvPr id="78" name="" descr="{&quot;isTemplate&quot;:true,&quot;type&quot;:&quot;text&quot;}"/>
+          <p:cNvPr id="79" name="" descr="{&quot;isTemplate&quot;:true,&quot;type&quot;:&quot;text&quot;}"/>
           <p:cNvSpPr txBox="1"/>
           <p:nvPr/>
         </p:nvSpPr>
@@ -6773,7 +6863,7 @@
       </p:sp>
       <p:sp>
         <p:nvSpPr>
-          <p:cNvPr id="79" name="" descr="{&quot;isTemplate&quot;:true,&quot;type&quot;:&quot;text&quot;}"/>
+          <p:cNvPr id="80" name="" descr="{&quot;isTemplate&quot;:true,&quot;type&quot;:&quot;text&quot;}"/>
           <p:cNvSpPr txBox="1"/>
           <p:nvPr/>
         </p:nvSpPr>
@@ -6826,7 +6916,7 @@
       </p:sp>
       <p:sp>
         <p:nvSpPr>
-          <p:cNvPr id="80" name="" descr="{&quot;isTemplate&quot;:true,&quot;type&quot;:&quot;text&quot;}"/>
+          <p:cNvPr id="81" name="" descr="{&quot;isTemplate&quot;:true,&quot;type&quot;:&quot;text&quot;}"/>
           <p:cNvSpPr txBox="1"/>
           <p:nvPr/>
         </p:nvSpPr>
@@ -6861,7 +6951,7 @@
       </p:sp>
       <p:sp>
         <p:nvSpPr>
-          <p:cNvPr id="81" name="" descr="{&quot;isTemplate&quot;:true,&quot;type&quot;:&quot;text&quot;}"/>
+          <p:cNvPr id="82" name="" descr="{&quot;isTemplate&quot;:true,&quot;type&quot;:&quot;text&quot;}"/>
           <p:cNvSpPr txBox="1"/>
           <p:nvPr/>
         </p:nvSpPr>
@@ -6896,7 +6986,7 @@
       </p:sp>
       <p:sp>
         <p:nvSpPr>
-          <p:cNvPr id="82" name="" descr="{&quot;isTemplate&quot;:true,&quot;type&quot;:&quot;text&quot;}"/>
+          <p:cNvPr id="83" name="" descr="{&quot;isTemplate&quot;:true,&quot;type&quot;:&quot;text&quot;}"/>
           <p:cNvSpPr txBox="1"/>
           <p:nvPr/>
         </p:nvSpPr>
@@ -6951,7 +7041,7 @@
       </p:sp>
       <p:sp>
         <p:nvSpPr>
-          <p:cNvPr id="83" name="" descr="{&quot;isTemplate&quot;:true,&quot;type&quot;:&quot;text&quot;}"/>
+          <p:cNvPr id="84" name="" descr="{&quot;isTemplate&quot;:true,&quot;type&quot;:&quot;text&quot;}"/>
           <p:cNvSpPr txBox="1"/>
           <p:nvPr/>
         </p:nvSpPr>
@@ -6986,7 +7076,7 @@
       </p:sp>
       <p:sp>
         <p:nvSpPr>
-          <p:cNvPr id="84" name="" descr="{&quot;isTemplate&quot;:true,&quot;type&quot;:&quot;text&quot;}"/>
+          <p:cNvPr id="85" name="" descr="{&quot;isTemplate&quot;:true,&quot;type&quot;:&quot;text&quot;}"/>
           <p:cNvSpPr txBox="1"/>
           <p:nvPr/>
         </p:nvSpPr>
@@ -7021,7 +7111,7 @@
       </p:sp>
       <p:sp>
         <p:nvSpPr>
-          <p:cNvPr id="85" name="" descr="{&quot;isTemplate&quot;:true,&quot;type&quot;:&quot;text&quot;}"/>
+          <p:cNvPr id="86" name="" descr="{&quot;isTemplate&quot;:true,&quot;type&quot;:&quot;text&quot;}"/>
           <p:cNvSpPr txBox="1"/>
           <p:nvPr/>
         </p:nvSpPr>
@@ -7096,7 +7186,7 @@
       </p:sp>
       <p:sp>
         <p:nvSpPr>
-          <p:cNvPr id="86" name="" descr="{&quot;isTemplate&quot;:true,&quot;type&quot;:&quot;text&quot;}"/>
+          <p:cNvPr id="87" name="" descr="{&quot;isTemplate&quot;:true,&quot;type&quot;:&quot;text&quot;}"/>
           <p:cNvSpPr txBox="1"/>
           <p:nvPr/>
         </p:nvSpPr>
@@ -7131,7 +7221,7 @@
       </p:sp>
       <p:sp>
         <p:nvSpPr>
-          <p:cNvPr id="87" name="" descr="{&quot;isTemplate&quot;:true,&quot;type&quot;:&quot;text&quot;}"/>
+          <p:cNvPr id="88" name="" descr="{&quot;isTemplate&quot;:true,&quot;type&quot;:&quot;text&quot;}"/>
           <p:cNvSpPr txBox="1"/>
           <p:nvPr/>
         </p:nvSpPr>
@@ -7166,7 +7256,7 @@
       </p:sp>
       <p:sp>
         <p:nvSpPr>
-          <p:cNvPr id="88" name="" descr="{&quot;isTemplate&quot;:true,&quot;type&quot;:&quot;text&quot;}"/>
+          <p:cNvPr id="89" name="" descr="{&quot;isTemplate&quot;:true,&quot;type&quot;:&quot;text&quot;}"/>
           <p:cNvSpPr txBox="1"/>
           <p:nvPr/>
         </p:nvSpPr>
@@ -7221,7 +7311,7 @@
       </p:sp>
       <p:sp>
         <p:nvSpPr>
-          <p:cNvPr id="89" name="" descr="{&quot;isTemplate&quot;:true,&quot;type&quot;:&quot;text&quot;}"/>
+          <p:cNvPr id="90" name="" descr="{&quot;isTemplate&quot;:true,&quot;type&quot;:&quot;text&quot;}"/>
           <p:cNvSpPr txBox="1"/>
           <p:nvPr/>
         </p:nvSpPr>
@@ -7256,7 +7346,7 @@
       </p:sp>
       <p:sp>
         <p:nvSpPr>
-          <p:cNvPr id="90" name="" descr="{&quot;isTemplate&quot;:true,&quot;type&quot;:&quot;text&quot;}"/>
+          <p:cNvPr id="91" name="" descr="{&quot;isTemplate&quot;:true,&quot;type&quot;:&quot;text&quot;}"/>
           <p:cNvSpPr txBox="1"/>
           <p:nvPr/>
         </p:nvSpPr>
@@ -7291,7 +7381,7 @@
       </p:sp>
       <p:sp>
         <p:nvSpPr>
-          <p:cNvPr id="91" name="" descr="{&quot;isTemplate&quot;:true,&quot;type&quot;:&quot;text&quot;}"/>
+          <p:cNvPr id="92" name="" descr="{&quot;isTemplate&quot;:true,&quot;type&quot;:&quot;text&quot;}"/>
           <p:cNvSpPr txBox="1"/>
           <p:nvPr/>
         </p:nvSpPr>
@@ -7367,41 +7457,6 @@
                             </p:stCondLst>
                             <p:childTnLst>
                               <p:par>
-                                <p:cTn id="148" presetID="10" presetClass="entr" presetSubtype="0" fill="hold" grpId="0" nodeType="withEffect">
-                                  <p:stCondLst>
-                                    <p:cond delay="0"/>
-                                  </p:stCondLst>
-                                  <p:childTnLst>
-                                    <p:set>
-                                      <p:cBhvr>
-                                        <p:cTn id="149" dur="1" fill="hold">
-                                          <p:stCondLst>
-                                            <p:cond delay="0"/>
-                                          </p:stCondLst>
-                                        </p:cTn>
-                                        <p:tgtEl>
-                                          <p:spTgt spid="80"/>
-                                        </p:tgtEl>
-                                        <p:attrNameLst>
-                                          <p:attrName>style.visibility</p:attrName>
-                                        </p:attrNameLst>
-                                      </p:cBhvr>
-                                      <p:to>
-                                        <p:strVal val="visible"/>
-                                      </p:to>
-                                    </p:set>
-                                    <p:animEffect transition="in" filter="fade">
-                                      <p:cBhvr>
-                                        <p:cTn id="150" dur="600"/>
-                                        <p:tgtEl>
-                                          <p:spTgt spid="80"/>
-                                        </p:tgtEl>
-                                      </p:cBhvr>
-                                    </p:animEffect>
-                                  </p:childTnLst>
-                                </p:cTn>
-                              </p:par>
-                              <p:par>
                                 <p:cTn id="151" presetID="10" presetClass="entr" presetSubtype="0" fill="hold" grpId="0" nodeType="withEffect">
                                   <p:stCondLst>
                                     <p:cond delay="0"/>
@@ -7472,7 +7527,7 @@
                                 </p:cTn>
                               </p:par>
                               <p:par>
-                                <p:cTn id="157" presetID="10" presetClass="entr" presetSubtype="0" fill="hold" grpId="1" nodeType="withEffect">
+                                <p:cTn id="157" presetID="10" presetClass="entr" presetSubtype="0" fill="hold" grpId="0" nodeType="withEffect">
                                   <p:stCondLst>
                                     <p:cond delay="0"/>
                                   </p:stCondLst>
@@ -7485,7 +7540,7 @@
                                           </p:stCondLst>
                                         </p:cTn>
                                         <p:tgtEl>
-                                          <p:spTgt spid="84"/>
+                                          <p:spTgt spid="83"/>
                                         </p:tgtEl>
                                         <p:attrNameLst>
                                           <p:attrName>style.visibility</p:attrName>
@@ -7499,7 +7554,7 @@
                                       <p:cBhvr>
                                         <p:cTn id="159" dur="600"/>
                                         <p:tgtEl>
-                                          <p:spTgt spid="84"/>
+                                          <p:spTgt spid="83"/>
                                         </p:tgtEl>
                                       </p:cBhvr>
                                     </p:animEffect>
@@ -7542,7 +7597,7 @@
                                 </p:cTn>
                               </p:par>
                               <p:par>
-                                <p:cTn id="163" presetID="10" presetClass="entr" presetSubtype="0" fill="hold" grpId="2" nodeType="withEffect">
+                                <p:cTn id="163" presetID="10" presetClass="entr" presetSubtype="0" fill="hold" grpId="1" nodeType="withEffect">
                                   <p:stCondLst>
                                     <p:cond delay="0"/>
                                   </p:stCondLst>
@@ -7555,7 +7610,7 @@
                                           </p:stCondLst>
                                         </p:cTn>
                                         <p:tgtEl>
-                                          <p:spTgt spid="87"/>
+                                          <p:spTgt spid="86"/>
                                         </p:tgtEl>
                                         <p:attrNameLst>
                                           <p:attrName>style.visibility</p:attrName>
@@ -7569,7 +7624,7 @@
                                       <p:cBhvr>
                                         <p:cTn id="165" dur="600"/>
                                         <p:tgtEl>
-                                          <p:spTgt spid="87"/>
+                                          <p:spTgt spid="86"/>
                                         </p:tgtEl>
                                       </p:cBhvr>
                                     </p:animEffect>
@@ -7612,7 +7667,7 @@
                                 </p:cTn>
                               </p:par>
                               <p:par>
-                                <p:cTn id="169" presetID="10" presetClass="entr" presetSubtype="0" fill="hold" grpId="3" nodeType="withEffect">
+                                <p:cTn id="169" presetID="10" presetClass="entr" presetSubtype="0" fill="hold" grpId="2" nodeType="withEffect">
                                   <p:stCondLst>
                                     <p:cond delay="0"/>
                                   </p:stCondLst>
@@ -7625,7 +7680,7 @@
                                           </p:stCondLst>
                                         </p:cTn>
                                         <p:tgtEl>
-                                          <p:spTgt spid="90"/>
+                                          <p:spTgt spid="89"/>
                                         </p:tgtEl>
                                         <p:attrNameLst>
                                           <p:attrName>style.visibility</p:attrName>
@@ -7639,7 +7694,7 @@
                                       <p:cBhvr>
                                         <p:cTn id="171" dur="600"/>
                                         <p:tgtEl>
-                                          <p:spTgt spid="90"/>
+                                          <p:spTgt spid="89"/>
                                         </p:tgtEl>
                                       </p:cBhvr>
                                     </p:animEffect>
@@ -7675,6 +7730,41 @@
                                         <p:cTn id="174" dur="600"/>
                                         <p:tgtEl>
                                           <p:spTgt spid="91"/>
+                                        </p:tgtEl>
+                                      </p:cBhvr>
+                                    </p:animEffect>
+                                  </p:childTnLst>
+                                </p:cTn>
+                              </p:par>
+                              <p:par>
+                                <p:cTn id="175" presetID="10" presetClass="entr" presetSubtype="0" fill="hold" grpId="3" nodeType="withEffect">
+                                  <p:stCondLst>
+                                    <p:cond delay="0"/>
+                                  </p:stCondLst>
+                                  <p:childTnLst>
+                                    <p:set>
+                                      <p:cBhvr>
+                                        <p:cTn id="176" dur="1" fill="hold">
+                                          <p:stCondLst>
+                                            <p:cond delay="0"/>
+                                          </p:stCondLst>
+                                        </p:cTn>
+                                        <p:tgtEl>
+                                          <p:spTgt spid="92"/>
+                                        </p:tgtEl>
+                                        <p:attrNameLst>
+                                          <p:attrName>style.visibility</p:attrName>
+                                        </p:attrNameLst>
+                                      </p:cBhvr>
+                                      <p:to>
+                                        <p:strVal val="visible"/>
+                                      </p:to>
+                                    </p:set>
+                                    <p:animEffect transition="in" filter="fade">
+                                      <p:cBhvr>
+                                        <p:cTn id="177" dur="600"/>
+                                        <p:tgtEl>
+                                          <p:spTgt spid="92"/>
                                         </p:tgtEl>
                                       </p:cBhvr>
                                     </p:animEffect>
@@ -7691,20 +7781,20 @@
                             </p:stCondLst>
                             <p:childTnLst>
                               <p:par>
-                                <p:cTn id="175" presetID="10" presetClass="entr" presetSubtype="0" fill="hold" grpId="1" nodeType="afterEffect">
+                                <p:cTn id="178" presetID="10" presetClass="entr" presetSubtype="0" fill="hold" grpId="1" nodeType="afterEffect">
                                   <p:stCondLst>
                                     <p:cond delay="0"/>
                                   </p:stCondLst>
                                   <p:childTnLst>
                                     <p:set>
                                       <p:cBhvr>
-                                        <p:cTn id="176" dur="1" fill="hold">
+                                        <p:cTn id="179" dur="1" fill="hold">
                                           <p:stCondLst>
                                             <p:cond delay="0"/>
                                           </p:stCondLst>
                                         </p:cTn>
                                         <p:tgtEl>
-                                          <p:spTgt spid="83"/>
+                                          <p:spTgt spid="84"/>
                                         </p:tgtEl>
                                         <p:attrNameLst>
                                           <p:attrName>style.visibility</p:attrName>
@@ -7716,9 +7806,9 @@
                                     </p:set>
                                     <p:animEffect transition="in" filter="fade">
                                       <p:cBhvr>
-                                        <p:cTn id="177" dur="600"/>
-                                        <p:tgtEl>
-                                          <p:spTgt spid="83"/>
+                                        <p:cTn id="180" dur="600"/>
+                                        <p:tgtEl>
+                                          <p:spTgt spid="84"/>
                                         </p:tgtEl>
                                       </p:cBhvr>
                                     </p:animEffect>
@@ -7735,20 +7825,20 @@
                             </p:stCondLst>
                             <p:childTnLst>
                               <p:par>
-                                <p:cTn id="178" presetID="10" presetClass="entr" presetSubtype="0" fill="hold" grpId="2" nodeType="afterEffect">
+                                <p:cTn id="181" presetID="10" presetClass="entr" presetSubtype="0" fill="hold" grpId="2" nodeType="afterEffect">
                                   <p:stCondLst>
                                     <p:cond delay="0"/>
                                   </p:stCondLst>
                                   <p:childTnLst>
                                     <p:set>
                                       <p:cBhvr>
-                                        <p:cTn id="179" dur="1" fill="hold">
+                                        <p:cTn id="182" dur="1" fill="hold">
                                           <p:stCondLst>
                                             <p:cond delay="0"/>
                                           </p:stCondLst>
                                         </p:cTn>
                                         <p:tgtEl>
-                                          <p:spTgt spid="86"/>
+                                          <p:spTgt spid="87"/>
                                         </p:tgtEl>
                                         <p:attrNameLst>
                                           <p:attrName>style.visibility</p:attrName>
@@ -7760,9 +7850,9 @@
                                     </p:set>
                                     <p:animEffect transition="in" filter="fade">
                                       <p:cBhvr>
-                                        <p:cTn id="180" dur="600"/>
-                                        <p:tgtEl>
-                                          <p:spTgt spid="86"/>
+                                        <p:cTn id="183" dur="600"/>
+                                        <p:tgtEl>
+                                          <p:spTgt spid="87"/>
                                         </p:tgtEl>
                                       </p:cBhvr>
                                     </p:animEffect>
@@ -7779,20 +7869,20 @@
                             </p:stCondLst>
                             <p:childTnLst>
                               <p:par>
-                                <p:cTn id="181" presetID="10" presetClass="entr" presetSubtype="0" fill="hold" grpId="3" nodeType="afterEffect">
+                                <p:cTn id="184" presetID="10" presetClass="entr" presetSubtype="0" fill="hold" grpId="3" nodeType="afterEffect">
                                   <p:stCondLst>
                                     <p:cond delay="0"/>
                                   </p:stCondLst>
                                   <p:childTnLst>
                                     <p:set>
                                       <p:cBhvr>
-                                        <p:cTn id="182" dur="1" fill="hold">
+                                        <p:cTn id="185" dur="1" fill="hold">
                                           <p:stCondLst>
                                             <p:cond delay="0"/>
                                           </p:stCondLst>
                                         </p:cTn>
                                         <p:tgtEl>
-                                          <p:spTgt spid="89"/>
+                                          <p:spTgt spid="90"/>
                                         </p:tgtEl>
                                         <p:attrNameLst>
                                           <p:attrName>style.visibility</p:attrName>
@@ -7804,9 +7894,9 @@
                                     </p:set>
                                     <p:animEffect transition="in" filter="fade">
                                       <p:cBhvr>
-                                        <p:cTn id="183" dur="600"/>
-                                        <p:tgtEl>
-                                          <p:spTgt spid="89"/>
+                                        <p:cTn id="186" dur="600"/>
+                                        <p:tgtEl>
+                                          <p:spTgt spid="90"/>
                                         </p:tgtEl>
                                       </p:cBhvr>
                                     </p:animEffect>
@@ -7845,7 +7935,7 @@
   <p:cSld>
     <p:spTree>
       <p:nvGrpSpPr>
-        <p:cNvPr id="92" name="" descr="&lt;Slide type=&quot;section&quot;&gt;&#10;  &lt;Box style={{ position: 'relative', width: '100%', height: '100%', background: '#0B1120' }}&gt;&#10;    &lt;Image src=&quot;assets/starlink_coverage.svg&quot; style={{ position: 'absolute', top: 0, left: 0, width: '100%', height: '100%', objectFit: 'cover', opacity: 0.4 }} /&gt;&#10;    &lt;Box style={{ position: 'absolute', top: 0, left: 0, width: '100%', height: '100%', background: 'linear-gradient(120deg, rgba(11,17,32,0.9) 0%, rgba(11,17,32,0.5) 100%)' }} /&gt;&#10;    &lt;Box style={{ position: 'relative', zIndex: 2, height: '100%', justifyContent: 'center', padding: '0 96px' }}&gt;&#10;      &lt;Animation animType=&quot;fadeIn&quot; duration={700}&gt;&#10;        &lt;Text style={{ fontSize: 34, color: '#22D3EE', fontWeight: 'bold', letterSpacing: 4 }}&gt;CHAPTER 01&lt;/Text&gt;&#10;      &lt;/Animation&gt;&#10;      &lt;Animation animType=&quot;fadeIn&quot; startType=&quot;afterPrevious&quot; duration={700}&gt;&#10;        &lt;Text style={{ fontSize: 60, color: '#E5EDF7', fontWeight: 'bold', marginTop: 16 }}&gt;项目总览&lt;/Text&gt;&#10;      &lt;/Animation&gt;&#10;      &lt;Animation animType=&quot;fadeIn&quot; startType=&quot;afterPrevious&quot; duration={700}&gt;&#10;        &lt;Text style={{ fontSize: 22, color: '#94A3B8', marginTop: 22 }}&gt;把一台扫地机器人，改装成能在地外作业的宇宙挖矿机器人&lt;/Text&gt;&#10;      &lt;/Animation&gt;&#10;    &lt;/Box&gt;&#10;  &lt;/Box&gt;&#10;&lt;/Slide&gt;&#10;"/>
+        <p:cNvPr id="93" name="" descr="&lt;Slide type=&quot;section&quot;&gt;&#10;  &lt;Box style={{ position: 'relative', width: '100%', height: '100%', background: '#0B1120' }}&gt;&#10;    &lt;Image src=&quot;assets/starlink_coverage.svg&quot; style={{ position: 'absolute', top: 0, left: 0, width: '100%', height: '100%', objectFit: 'cover', opacity: 0.4 }} /&gt;&#10;    &lt;Box style={{ position: 'absolute', top: 0, left: 0, width: '100%', height: '100%', background: 'linear-gradient(120deg, rgba(11,17,32,0.9) 0%, rgba(11,17,32,0.5) 100%)' }} /&gt;&#10;    &lt;Box style={{ position: 'relative', zIndex: 2, height: '100%', justifyContent: 'center', padding: '0 96px' }}&gt;&#10;      &lt;Animation animType=&quot;fadeIn&quot; duration={700}&gt;&#10;        &lt;Text style={{ fontSize: 34, color: '#22D3EE', fontWeight: 'bold', letterSpacing: 4 }}&gt;CHAPTER 01&lt;/Text&gt;&#10;      &lt;/Animation&gt;&#10;      &lt;Animation animType=&quot;fadeIn&quot; startType=&quot;afterPrevious&quot; duration={700}&gt;&#10;        &lt;Text style={{ fontSize: 60, color: '#E5EDF7', fontWeight: 'bold', marginTop: 16 }}&gt;项目总览&lt;/Text&gt;&#10;      &lt;/Animation&gt;&#10;      &lt;Animation animType=&quot;fadeIn&quot; startType=&quot;afterPrevious&quot; duration={700}&gt;&#10;        &lt;Text style={{ fontSize: 22, color: '#94A3B8', marginTop: 22 }}&gt;把一台扫地机器人，改装成能在地外作业的宇宙挖矿机器人&lt;/Text&gt;&#10;      &lt;/Animation&gt;&#10;    &lt;/Box&gt;&#10;  &lt;/Box&gt;&#10;&lt;/Slide&gt;&#10;"/>
         <p:cNvGrpSpPr/>
         <p:nvPr/>
       </p:nvGrpSpPr>
@@ -7859,7 +7949,7 @@
       </p:grpSpPr>
       <p:sp>
         <p:nvSpPr>
-          <p:cNvPr id="93" name=""/>
+          <p:cNvPr id="94" name=""/>
           <p:cNvSpPr/>
           <p:nvPr/>
         </p:nvSpPr>
@@ -7883,7 +7973,7 @@
       </p:sp>
       <p:pic>
         <p:nvPicPr>
-          <p:cNvPr id="94" name=""/>
+          <p:cNvPr id="95" name=""/>
           <p:cNvPicPr>
             <a:picLocks noChangeAspect="1"/>
           </p:cNvPicPr>
@@ -7916,7 +8006,7 @@
       </p:pic>
       <p:sp>
         <p:nvSpPr>
-          <p:cNvPr id="95" name=""/>
+          <p:cNvPr id="96" name=""/>
           <p:cNvSpPr/>
           <p:nvPr/>
         </p:nvSpPr>
@@ -7952,7 +8042,7 @@
       </p:sp>
       <p:sp>
         <p:nvSpPr>
-          <p:cNvPr id="96" name="" descr="{&quot;isTemplate&quot;:true,&quot;type&quot;:&quot;text&quot;}"/>
+          <p:cNvPr id="97" name="" descr="{&quot;isTemplate&quot;:true,&quot;type&quot;:&quot;text&quot;}"/>
           <p:cNvSpPr txBox="1"/>
           <p:nvPr/>
         </p:nvSpPr>
@@ -7987,7 +8077,7 @@
       </p:sp>
       <p:sp>
         <p:nvSpPr>
-          <p:cNvPr id="97" name="" descr="{&quot;isTemplate&quot;:true,&quot;type&quot;:&quot;text&quot;}"/>
+          <p:cNvPr id="98" name="" descr="{&quot;isTemplate&quot;:true,&quot;type&quot;:&quot;text&quot;}"/>
           <p:cNvSpPr txBox="1"/>
           <p:nvPr/>
         </p:nvSpPr>
@@ -8022,7 +8112,7 @@
       </p:sp>
       <p:sp>
         <p:nvSpPr>
-          <p:cNvPr id="98" name="" descr="{&quot;isTemplate&quot;:true,&quot;type&quot;:&quot;text&quot;}"/>
+          <p:cNvPr id="99" name="" descr="{&quot;isTemplate&quot;:true,&quot;type&quot;:&quot;text&quot;}"/>
           <p:cNvSpPr txBox="1"/>
           <p:nvPr/>
         </p:nvSpPr>
@@ -8078,20 +8168,20 @@
                             </p:stCondLst>
                             <p:childTnLst>
                               <p:par>
-                                <p:cTn id="184" presetID="10" presetClass="entr" presetSubtype="0" fill="hold" grpId="0" nodeType="withEffect">
+                                <p:cTn id="187" presetID="10" presetClass="entr" presetSubtype="0" fill="hold" grpId="0" nodeType="withEffect">
                                   <p:stCondLst>
                                     <p:cond delay="0"/>
                                   </p:stCondLst>
                                   <p:childTnLst>
                                     <p:set>
                                       <p:cBhvr>
-                                        <p:cTn id="185" dur="1" fill="hold">
+                                        <p:cTn id="188" dur="1" fill="hold">
                                           <p:stCondLst>
                                             <p:cond delay="0"/>
                                           </p:stCondLst>
                                         </p:cTn>
                                         <p:tgtEl>
-                                          <p:spTgt spid="96"/>
+                                          <p:spTgt spid="97"/>
                                         </p:tgtEl>
                                         <p:attrNameLst>
                                           <p:attrName>style.visibility</p:attrName>
@@ -8103,9 +8193,9 @@
                                     </p:set>
                                     <p:animEffect transition="in" filter="fade">
                                       <p:cBhvr>
-                                        <p:cTn id="186" dur="700"/>
-                                        <p:tgtEl>
-                                          <p:spTgt spid="96"/>
+                                        <p:cTn id="189" dur="700"/>
+                                        <p:tgtEl>
+                                          <p:spTgt spid="97"/>
                                         </p:tgtEl>
                                       </p:cBhvr>
                                     </p:animEffect>
@@ -8122,20 +8212,20 @@
                             </p:stCondLst>
                             <p:childTnLst>
                               <p:par>
-                                <p:cTn id="187" presetID="10" presetClass="entr" presetSubtype="0" fill="hold" grpId="1" nodeType="afterEffect">
+                                <p:cTn id="190" presetID="10" presetClass="entr" presetSubtype="0" fill="hold" grpId="1" nodeType="afterEffect">
                                   <p:stCondLst>
                                     <p:cond delay="0"/>
                                   </p:stCondLst>
                                   <p:childTnLst>
                                     <p:set>
                                       <p:cBhvr>
-                                        <p:cTn id="188" dur="1" fill="hold">
+                                        <p:cTn id="191" dur="1" fill="hold">
                                           <p:stCondLst>
                                             <p:cond delay="0"/>
                                           </p:stCondLst>
                                         </p:cTn>
                                         <p:tgtEl>
-                                          <p:spTgt spid="97"/>
+                                          <p:spTgt spid="98"/>
                                         </p:tgtEl>
                                         <p:attrNameLst>
                                           <p:attrName>style.visibility</p:attrName>
@@ -8147,9 +8237,9 @@
                                     </p:set>
                                     <p:animEffect transition="in" filter="fade">
                                       <p:cBhvr>
-                                        <p:cTn id="189" dur="700"/>
-                                        <p:tgtEl>
-                                          <p:spTgt spid="97"/>
+                                        <p:cTn id="192" dur="700"/>
+                                        <p:tgtEl>
+                                          <p:spTgt spid="98"/>
                                         </p:tgtEl>
                                       </p:cBhvr>
                                     </p:animEffect>
@@ -8166,20 +8256,20 @@
                             </p:stCondLst>
                             <p:childTnLst>
                               <p:par>
-                                <p:cTn id="190" presetID="10" presetClass="entr" presetSubtype="0" fill="hold" grpId="2" nodeType="afterEffect">
+                                <p:cTn id="193" presetID="10" presetClass="entr" presetSubtype="0" fill="hold" grpId="2" nodeType="afterEffect">
                                   <p:stCondLst>
                                     <p:cond delay="0"/>
                                   </p:stCondLst>
                                   <p:childTnLst>
                                     <p:set>
                                       <p:cBhvr>
-                                        <p:cTn id="191" dur="1" fill="hold">
+                                        <p:cTn id="194" dur="1" fill="hold">
                                           <p:stCondLst>
                                             <p:cond delay="0"/>
                                           </p:stCondLst>
                                         </p:cTn>
                                         <p:tgtEl>
-                                          <p:spTgt spid="98"/>
+                                          <p:spTgt spid="99"/>
                                         </p:tgtEl>
                                         <p:attrNameLst>
                                           <p:attrName>style.visibility</p:attrName>
@@ -8191,9 +8281,9 @@
                                     </p:set>
                                     <p:animEffect transition="in" filter="fade">
                                       <p:cBhvr>
-                                        <p:cTn id="192" dur="700"/>
-                                        <p:tgtEl>
-                                          <p:spTgt spid="98"/>
+                                        <p:cTn id="195" dur="700"/>
+                                        <p:tgtEl>
+                                          <p:spTgt spid="99"/>
                                         </p:tgtEl>
                                       </p:cBhvr>
                                     </p:animEffect>
@@ -8232,7 +8322,7 @@
   <p:cSld>
     <p:spTree>
       <p:nvGrpSpPr>
-        <p:cNvPr id="99" name="" descr="&lt;Slide type=&quot;content&quot;&gt;&#10;  &lt;Box style={{ width: '100%', height: '100%', background: '#0B1120', flexDirection: 'row' }}&gt;&#10;    &lt;Box style={{ width: '56%', height: '100%', justifyContent: 'center', alignItems: 'center', padding: '44px' }}&gt;&#10;      &lt;Image src=&quot;assets/system_architecture.svg&quot; style={{ width: '100%', height: '100%', objectFit: 'contain' }} /&gt;&#10;    &lt;/Box&gt;&#10;    &lt;Box style={{ flex: 1, justifyContent: 'center', padding: '0 52px', gap: 16 }}&gt;&#10;      &lt;Animation animType=&quot;fadeIn&quot; duration={600}&gt;&#10;        &lt;Text style={{ fontSize: 34, color: '#E5EDF7', fontWeight: 'bold' }}&gt;整体系统架构&lt;/Text&gt;&#10;      &lt;/Animation&gt;&#10;      &lt;Animation animType=&quot;fadeIn&quot; startType=&quot;afterPrevious&quot; duration={600}&gt;&#10;        &lt;Text style={{ fontSize: 17, color: '#94A3B8', lineHeight: 1.75 }}&gt;&#10;          一台 CMR 由五层构成，从成熟消费底座一路改装到地外作业闭环：移动底座 → 不锈钢抗辐照机身 → 第三代半导体抗辐射算力 → 多光谱感知与钻采工具头 → 星链通讯 + 区块链账本。&#10;        &lt;/Text&gt;&#10;      &lt;/Animation&gt;&#10;      &lt;Animation animType=&quot;fadeIn&quot; startType=&quot;afterPrevious&quot; duration={600}&gt;&#10;        &lt;Box style={{ gap: 10, marginTop: 6 }}&gt;&#10;          &lt;Box style={{ flexDirection: 'row', gap: 12, alignItems: 'center' }}&gt;&lt;Text style={{ fontSize: 18, color: '#3B82F6', fontWeight: 'bold' }}&gt;①&lt;/Text&gt;&lt;Text style={{ fontSize: 16, color: '#CBD5E1' }}&gt;移动底座：扫地机器人底盘 + SLAM 导航（oomwoo 开源）&lt;/Text&gt;&lt;/Box&gt;&#10;          &lt;Box style={{ flexDirection: 'row', gap: 12, alignItems: 'center' }}&gt;&lt;Text style={{ fontSize: 18, color: '#22D3EE', fontWeight: 'bold' }}&gt;②&lt;/Text&gt;&lt;Text style={{ fontSize: 16, color: '#CBD5E1' }}&gt;机身：316L 不锈钢外壳，兼顾散热 / 抗粒子 / 强度&lt;/Text&gt;&lt;/Box&gt;&#10;          &lt;Box style={{ flexDirection: 'row', gap: 12, alignItems: 'center' }}&gt;&lt;Text style={{ fontSize: 18, color: '#F59E0B', fontWeight: 'bold' }}&gt;③&lt;/Text&gt;&lt;Text style={{ fontSize: 16, color: '#CBD5E1' }}&gt;算力：西电 SiC + 广州 GaN 中试 + 宇航级 SoC&lt;/Text&gt;&lt;/Box&gt;&#10;          &lt;Box style={{ flexDirection: 'row', gap: 12, alignItems: 'center' }}&gt;&lt;Text style={{ fontSize: 18, color: '#A78BFA', fontWeight: 'bold' }}&gt;④&lt;/Text&gt;&lt;Text style={{ fontSize: 16, color: '#CBD5E1' }}&gt;作业：多光谱相机 + 钻采工具头识别采矿&lt;/Text&gt;&lt;/Box&gt;&#10;          &lt;Box style={{ flexDirection: 'row', gap: 12, alignItems: 'center' }}&gt;&lt;Text style={{ fontSize: 18, color: '#34D399', fontWeight: 'bold' }}&gt;⑤&lt;/Text&gt;&lt;Text style={{ fontSize: 16, color: '#CBD5E1' }}&gt;闭环：Starlink 回传 + 区块链溯源与资产化&lt;/Text&gt;&lt;/Box&gt;&#10;        &lt;/Box&gt;&#10;      &lt;/Animation&gt;&#10;    &lt;/Box&gt;&#10;  &lt;/Box&gt;&#10;&lt;/Slide&gt;&#10;"/>
+        <p:cNvPr id="100" name="" descr="&lt;Slide type=&quot;content&quot;&gt;&#10;  &lt;Box style={{ width: '100%', height: '100%', background: '#0B1120', flexDirection: 'row' }}&gt;&#10;    &lt;Box style={{ width: '56%', height: '100%', justifyContent: 'center', alignItems: 'center', padding: '44px' }}&gt;&#10;      &lt;Image src=&quot;assets/system_architecture.svg&quot; style={{ width: '100%', height: '100%', objectFit: 'contain' }} /&gt;&#10;    &lt;/Box&gt;&#10;    &lt;Box style={{ flex: 1, justifyContent: 'center', padding: '0 52px', gap: 16 }}&gt;&#10;      &lt;Animation animType=&quot;fadeIn&quot; duration={600}&gt;&#10;        &lt;Text style={{ fontSize: 34, color: '#E5EDF7', fontWeight: 'bold' }}&gt;整体系统架构&lt;/Text&gt;&#10;      &lt;/Animation&gt;&#10;      &lt;Animation animType=&quot;fadeIn&quot; startType=&quot;afterPrevious&quot; duration={600}&gt;&#10;        &lt;Text style={{ fontSize: 17, color: '#94A3B8', lineHeight: 1.75 }}&gt;&#10;          一台 CMR 由五层构成，从成熟消费底座一路改装到地外作业闭环：移动底座 → 不锈钢抗辐照机身 → 第三代半导体抗辐射算力 → 多光谱感知与钻采工具头 → 星链通讯 + 区块链账本。&#10;        &lt;/Text&gt;&#10;      &lt;/Animation&gt;&#10;      &lt;Animation animType=&quot;fadeIn&quot; startType=&quot;afterPrevious&quot; duration={600}&gt;&#10;        &lt;Box style={{ gap: 10, marginTop: 6 }}&gt;&#10;          &lt;Box style={{ flexDirection: 'row', gap: 12, alignItems: 'center' }}&gt;&lt;Text style={{ fontSize: 18, color: '#3B82F6', fontWeight: 'bold' }}&gt;①&lt;/Text&gt;&lt;Text style={{ fontSize: 16, color: '#CBD5E1' }}&gt;移动底座：扫地机器人底盘 + SLAM 导航（oomwoo 开源）&lt;/Text&gt;&lt;/Box&gt;&#10;          &lt;Box style={{ flexDirection: 'row', gap: 12, alignItems: 'center' }}&gt;&lt;Text style={{ fontSize: 18, color: '#22D3EE', fontWeight: 'bold' }}&gt;②&lt;/Text&gt;&lt;Text style={{ fontSize: 16, color: '#CBD5E1' }}&gt;机身：316L 不锈钢外壳，兼顾散热 / 抗粒子 / 强度&lt;/Text&gt;&lt;/Box&gt;&#10;          &lt;Box style={{ flexDirection: 'row', gap: 12, alignItems: 'center' }}&gt;&lt;Text style={{ fontSize: 18, color: '#F59E0B', fontWeight: 'bold' }}&gt;③&lt;/Text&gt;&lt;Text style={{ fontSize: 16, color: '#CBD5E1' }}&gt;算力：西电 SiC + 广州 GaN 中试 + 宇航级 SoC&lt;/Text&gt;&lt;/Box&gt;&#10;          &lt;Box style={{ flexDirection: 'row', gap: 12, alignItems: 'center' }}&gt;&lt;Text style={{ fontSize: 18, color: '#A78BFA', fontWeight: 'bold' }}&gt;④&lt;/Text&gt;&lt;Text style={{ fontSize: 16, color: '#CBD5E1' }}&gt;作业：多光谱相机 + 钻采工具头识别采矿&lt;/Text&gt;&lt;/Box&gt;&#10;          &lt;Box style={{ flexDirection: 'row', gap: 12, alignItems: 'center' }}&gt;&lt;Text style={{ fontSize: 18, color: '#34D399', fontWeight: 'bold' }}&gt;⑤&lt;/Text&gt;&lt;Text style={{ fontSize: 16, color: '#CBD5E1' }}&gt;闭环：Starlink 回传 + 区块链溯源与资产化&lt;/Text&gt;&lt;/Box&gt;&#10;        &lt;/Box&gt;&#10;      &lt;/Animation&gt;&#10;    &lt;/Box&gt;&#10;  &lt;/Box&gt;&#10;&lt;/Slide&gt;&#10;"/>
         <p:cNvGrpSpPr/>
         <p:nvPr/>
       </p:nvGrpSpPr>
@@ -8246,7 +8336,7 @@
       </p:grpSpPr>
       <p:sp>
         <p:nvSpPr>
-          <p:cNvPr id="100" name=""/>
+          <p:cNvPr id="101" name=""/>
           <p:cNvSpPr/>
           <p:nvPr/>
         </p:nvSpPr>
@@ -8270,7 +8360,7 @@
       </p:sp>
       <p:pic>
         <p:nvPicPr>
-          <p:cNvPr id="101" name=""/>
+          <p:cNvPr id="102" name=""/>
           <p:cNvPicPr>
             <a:picLocks noChangeAspect="1"/>
           </p:cNvPicPr>
@@ -8302,7 +8392,7 @@
       </p:pic>
       <p:sp>
         <p:nvSpPr>
-          <p:cNvPr id="102" name="" descr="{&quot;isTemplate&quot;:true,&quot;type&quot;:&quot;text&quot;}"/>
+          <p:cNvPr id="103" name="" descr="{&quot;isTemplate&quot;:true,&quot;type&quot;:&quot;text&quot;}"/>
           <p:cNvSpPr txBox="1"/>
           <p:nvPr/>
         </p:nvSpPr>
@@ -8337,7 +8427,7 @@
       </p:sp>
       <p:sp>
         <p:nvSpPr>
-          <p:cNvPr id="103" name="" descr="{&quot;isTemplate&quot;:true,&quot;type&quot;:&quot;text&quot;}"/>
+          <p:cNvPr id="104" name="" descr="{&quot;isTemplate&quot;:true,&quot;type&quot;:&quot;text&quot;}"/>
           <p:cNvSpPr txBox="1"/>
           <p:nvPr/>
         </p:nvSpPr>
@@ -8494,7 +8584,7 @@
       </p:sp>
       <p:sp>
         <p:nvSpPr>
-          <p:cNvPr id="104" name="" descr="{&quot;isTemplate&quot;:true,&quot;type&quot;:&quot;text&quot;}"/>
+          <p:cNvPr id="105" name="" descr="{&quot;isTemplate&quot;:true,&quot;type&quot;:&quot;text&quot;}"/>
           <p:cNvSpPr txBox="1"/>
           <p:nvPr/>
         </p:nvSpPr>
@@ -8529,7 +8619,7 @@
       </p:sp>
       <p:sp>
         <p:nvSpPr>
-          <p:cNvPr id="105" name="" descr="{&quot;isTemplate&quot;:true,&quot;type&quot;:&quot;text&quot;}"/>
+          <p:cNvPr id="106" name="" descr="{&quot;isTemplate&quot;:true,&quot;type&quot;:&quot;text&quot;}"/>
           <p:cNvSpPr txBox="1"/>
           <p:nvPr/>
         </p:nvSpPr>
@@ -8604,7 +8694,7 @@
       </p:sp>
       <p:sp>
         <p:nvSpPr>
-          <p:cNvPr id="106" name="" descr="{&quot;isTemplate&quot;:true,&quot;type&quot;:&quot;text&quot;}"/>
+          <p:cNvPr id="107" name="" descr="{&quot;isTemplate&quot;:true,&quot;type&quot;:&quot;text&quot;}"/>
           <p:cNvSpPr txBox="1"/>
           <p:nvPr/>
         </p:nvSpPr>
@@ -8639,7 +8729,7 @@
       </p:sp>
       <p:sp>
         <p:nvSpPr>
-          <p:cNvPr id="107" name="" descr="{&quot;isTemplate&quot;:true,&quot;type&quot;:&quot;text&quot;}"/>
+          <p:cNvPr id="108" name="" descr="{&quot;isTemplate&quot;:true,&quot;type&quot;:&quot;text&quot;}"/>
           <p:cNvSpPr txBox="1"/>
           <p:nvPr/>
         </p:nvSpPr>
@@ -8734,7 +8824,7 @@
       </p:sp>
       <p:sp>
         <p:nvSpPr>
-          <p:cNvPr id="108" name="" descr="{&quot;isTemplate&quot;:true,&quot;type&quot;:&quot;text&quot;}"/>
+          <p:cNvPr id="109" name="" descr="{&quot;isTemplate&quot;:true,&quot;type&quot;:&quot;text&quot;}"/>
           <p:cNvSpPr txBox="1"/>
           <p:nvPr/>
         </p:nvSpPr>
@@ -8769,7 +8859,7 @@
       </p:sp>
       <p:sp>
         <p:nvSpPr>
-          <p:cNvPr id="109" name="" descr="{&quot;isTemplate&quot;:true,&quot;type&quot;:&quot;text&quot;}"/>
+          <p:cNvPr id="110" name="" descr="{&quot;isTemplate&quot;:true,&quot;type&quot;:&quot;text&quot;}"/>
           <p:cNvSpPr txBox="1"/>
           <p:nvPr/>
         </p:nvSpPr>
@@ -8874,7 +8964,7 @@
       </p:sp>
       <p:sp>
         <p:nvSpPr>
-          <p:cNvPr id="110" name="" descr="{&quot;isTemplate&quot;:true,&quot;type&quot;:&quot;text&quot;}"/>
+          <p:cNvPr id="111" name="" descr="{&quot;isTemplate&quot;:true,&quot;type&quot;:&quot;text&quot;}"/>
           <p:cNvSpPr txBox="1"/>
           <p:nvPr/>
         </p:nvSpPr>
@@ -8909,7 +8999,7 @@
       </p:sp>
       <p:sp>
         <p:nvSpPr>
-          <p:cNvPr id="111" name="" descr="{&quot;isTemplate&quot;:true,&quot;type&quot;:&quot;text&quot;}"/>
+          <p:cNvPr id="112" name="" descr="{&quot;isTemplate&quot;:true,&quot;type&quot;:&quot;text&quot;}"/>
           <p:cNvSpPr txBox="1"/>
           <p:nvPr/>
         </p:nvSpPr>
@@ -8964,7 +9054,7 @@
       </p:sp>
       <p:sp>
         <p:nvSpPr>
-          <p:cNvPr id="112" name="" descr="{&quot;isTemplate&quot;:true,&quot;type&quot;:&quot;text&quot;}"/>
+          <p:cNvPr id="113" name="" descr="{&quot;isTemplate&quot;:true,&quot;type&quot;:&quot;text&quot;}"/>
           <p:cNvSpPr txBox="1"/>
           <p:nvPr/>
         </p:nvSpPr>
@@ -8999,7 +9089,7 @@
       </p:sp>
       <p:sp>
         <p:nvSpPr>
-          <p:cNvPr id="113" name="" descr="{&quot;isTemplate&quot;:true,&quot;type&quot;:&quot;text&quot;}"/>
+          <p:cNvPr id="114" name="" descr="{&quot;isTemplate&quot;:true,&quot;type&quot;:&quot;text&quot;}"/>
           <p:cNvSpPr txBox="1"/>
           <p:nvPr/>
         </p:nvSpPr>
@@ -9095,20 +9185,20 @@
                             </p:stCondLst>
                             <p:childTnLst>
                               <p:par>
-                                <p:cTn id="193" presetID="10" presetClass="entr" presetSubtype="0" fill="hold" grpId="0" nodeType="withEffect">
+                                <p:cTn id="196" presetID="10" presetClass="entr" presetSubtype="0" fill="hold" grpId="0" nodeType="withEffect">
                                   <p:stCondLst>
                                     <p:cond delay="0"/>
                                   </p:stCondLst>
                                   <p:childTnLst>
                                     <p:set>
                                       <p:cBhvr>
-                                        <p:cTn id="194" dur="1" fill="hold">
+                                        <p:cTn id="197" dur="1" fill="hold">
                                           <p:stCondLst>
                                             <p:cond delay="0"/>
                                           </p:stCondLst>
                                         </p:cTn>
                                         <p:tgtEl>
-                                          <p:spTgt spid="102"/>
+                                          <p:spTgt spid="103"/>
                                         </p:tgtEl>
                                         <p:attrNameLst>
                                           <p:attrName>style.visibility</p:attrName>
@@ -9120,44 +9210,9 @@
                                     </p:set>
                                     <p:animEffect transition="in" filter="fade">
                                       <p:cBhvr>
-                                        <p:cTn id="195" dur="600"/>
-                                        <p:tgtEl>
-                                          <p:spTgt spid="102"/>
-                                        </p:tgtEl>
-                                      </p:cBhvr>
-                                    </p:animEffect>
-                                  </p:childTnLst>
-                                </p:cTn>
-                              </p:par>
-                              <p:par>
-                                <p:cTn id="196" presetID="10" presetClass="entr" presetSubtype="0" fill="hold" grpId="2" nodeType="withEffect">
-                                  <p:stCondLst>
-                                    <p:cond delay="0"/>
-                                  </p:stCondLst>
-                                  <p:childTnLst>
-                                    <p:set>
-                                      <p:cBhvr>
-                                        <p:cTn id="197" dur="1" fill="hold">
-                                          <p:stCondLst>
-                                            <p:cond delay="0"/>
-                                          </p:stCondLst>
-                                        </p:cTn>
-                                        <p:tgtEl>
-                                          <p:spTgt spid="105"/>
-                                        </p:tgtEl>
-                                        <p:attrNameLst>
-                                          <p:attrName>style.visibility</p:attrName>
-                                        </p:attrNameLst>
-                                      </p:cBhvr>
-                                      <p:to>
-                                        <p:strVal val="visible"/>
-                                      </p:to>
-                                    </p:set>
-                                    <p:animEffect transition="in" filter="fade">
-                                      <p:cBhvr>
                                         <p:cTn id="198" dur="600"/>
                                         <p:tgtEl>
-                                          <p:spTgt spid="105"/>
+                                          <p:spTgt spid="103"/>
                                         </p:tgtEl>
                                       </p:cBhvr>
                                     </p:animEffect>
@@ -9438,6 +9493,41 @@
                                         <p:cTn id="222" dur="600"/>
                                         <p:tgtEl>
                                           <p:spTgt spid="113"/>
+                                        </p:tgtEl>
+                                      </p:cBhvr>
+                                    </p:animEffect>
+                                  </p:childTnLst>
+                                </p:cTn>
+                              </p:par>
+                              <p:par>
+                                <p:cTn id="223" presetID="10" presetClass="entr" presetSubtype="0" fill="hold" grpId="2" nodeType="withEffect">
+                                  <p:stCondLst>
+                                    <p:cond delay="0"/>
+                                  </p:stCondLst>
+                                  <p:childTnLst>
+                                    <p:set>
+                                      <p:cBhvr>
+                                        <p:cTn id="224" dur="1" fill="hold">
+                                          <p:stCondLst>
+                                            <p:cond delay="0"/>
+                                          </p:stCondLst>
+                                        </p:cTn>
+                                        <p:tgtEl>
+                                          <p:spTgt spid="114"/>
+                                        </p:tgtEl>
+                                        <p:attrNameLst>
+                                          <p:attrName>style.visibility</p:attrName>
+                                        </p:attrNameLst>
+                                      </p:cBhvr>
+                                      <p:to>
+                                        <p:strVal val="visible"/>
+                                      </p:to>
+                                    </p:set>
+                                    <p:animEffect transition="in" filter="fade">
+                                      <p:cBhvr>
+                                        <p:cTn id="225" dur="600"/>
+                                        <p:tgtEl>
+                                          <p:spTgt spid="114"/>
                                         </p:tgtEl>
                                       </p:cBhvr>
                                     </p:animEffect>
@@ -9454,20 +9544,20 @@
                             </p:stCondLst>
                             <p:childTnLst>
                               <p:par>
-                                <p:cTn id="223" presetID="10" presetClass="entr" presetSubtype="0" fill="hold" grpId="1" nodeType="afterEffect">
+                                <p:cTn id="226" presetID="10" presetClass="entr" presetSubtype="0" fill="hold" grpId="1" nodeType="afterEffect">
                                   <p:stCondLst>
                                     <p:cond delay="0"/>
                                   </p:stCondLst>
                                   <p:childTnLst>
                                     <p:set>
                                       <p:cBhvr>
-                                        <p:cTn id="224" dur="1" fill="hold">
+                                        <p:cTn id="227" dur="1" fill="hold">
                                           <p:stCondLst>
                                             <p:cond delay="0"/>
                                           </p:stCondLst>
                                         </p:cTn>
                                         <p:tgtEl>
-                                          <p:spTgt spid="103"/>
+                                          <p:spTgt spid="104"/>
                                         </p:tgtEl>
                                         <p:attrNameLst>
                                           <p:attrName>style.visibility</p:attrName>
@@ -9479,9 +9569,9 @@
                                     </p:set>
                                     <p:animEffect transition="in" filter="fade">
                                       <p:cBhvr>
-                                        <p:cTn id="225" dur="600"/>
-                                        <p:tgtEl>
-                                          <p:spTgt spid="103"/>
+                                        <p:cTn id="228" dur="600"/>
+                                        <p:tgtEl>
+                                          <p:spTgt spid="104"/>
                                         </p:tgtEl>
                                       </p:cBhvr>
                                     </p:animEffect>
@@ -9498,20 +9588,20 @@
                             </p:stCondLst>
                             <p:childTnLst>
                               <p:par>
-                                <p:cTn id="226" presetID="10" presetClass="entr" presetSubtype="0" fill="hold" grpId="2" nodeType="afterEffect">
+                                <p:cTn id="229" presetID="10" presetClass="entr" presetSubtype="0" fill="hold" grpId="2" nodeType="afterEffect">
                                   <p:stCondLst>
                                     <p:cond delay="0"/>
                                   </p:stCondLst>
                                   <p:childTnLst>
                                     <p:set>
                                       <p:cBhvr>
-                                        <p:cTn id="227" dur="1" fill="hold">
+                                        <p:cTn id="230" dur="1" fill="hold">
                                           <p:stCondLst>
                                             <p:cond delay="0"/>
                                           </p:stCondLst>
                                         </p:cTn>
                                         <p:tgtEl>
-                                          <p:spTgt spid="104"/>
+                                          <p:spTgt spid="105"/>
                                         </p:tgtEl>
                                         <p:attrNameLst>
                                           <p:attrName>style.visibility</p:attrName>
@@ -9523,9 +9613,9 @@
                                     </p:set>
                                     <p:animEffect transition="in" filter="fade">
                                       <p:cBhvr>
-                                        <p:cTn id="228" dur="600"/>
-                                        <p:tgtEl>
-                                          <p:spTgt spid="104"/>
+                                        <p:cTn id="231" dur="600"/>
+                                        <p:tgtEl>
+                                          <p:spTgt spid="105"/>
                                         </p:tgtEl>
                                       </p:cBhvr>
                                     </p:animEffect>
@@ -9564,7 +9654,7 @@
   <p:cSld>
     <p:spTree>
       <p:nvGrpSpPr>
-        <p:cNvPr id="114" name="" descr="&lt;Slide type=&quot;content&quot;&gt;&#10;  &lt;Box style={{ width: '100%', height: '100%', background: '#0B1120', flexDirection: 'row' }}&gt;&#10;    &lt;Box style={{ width: '60%', height: '100%', justifyContent: 'center', padding: '0 56px', gap: 14 }}&gt;&#10;      &lt;Animation animType=&quot;fadeIn&quot; duration={600}&gt;&#10;        &lt;Text style={{ fontSize: 32, color: '#E5EDF7', fontWeight: 'bold' }}&gt;改装逻辑：为什么是扫地机器人&lt;/Text&gt;&#10;      &lt;/Animation&gt;&#10;      &lt;Animation animType=&quot;fadeIn&quot; startType=&quot;afterPrevious&quot; duration={600}&gt;&#10;        &lt;Text style={{ fontSize: 17, color: '#94A3B8', lineHeight: 1.8 }}&gt;&#10;          改装不是从零造机器人，而是「站在量产肩膀上」。消费级扫地机器人已经解决了最难的移动与自主问题，我们只需替换上身与作业模块，就能把清洁能力翻转成采矿能力。&#10;        &lt;/Text&gt;&#10;      &lt;/Animation&gt;&#10;      &lt;Animation animType=&quot;fadeIn&quot; startType=&quot;afterPrevious&quot; duration={600}&gt;&#10;        &lt;Box style={{ gap: 12, marginTop: 6 }}&gt;&#10;          &lt;Text style={{ fontSize: 16, color: '#CBD5E1', lineHeight: 1.7 }}&gt;· 成熟底盘：量产轮组 / 电池 / IMU，免从零研发&lt;/Text&gt;&#10;          &lt;Text style={{ fontSize: 16, color: '#CBD5E1', lineHeight: 1.7 }}&gt;· 自主导航：ROS2 + Nav2 全覆盖路径，直接复用&lt;/Text&gt;&#10;          &lt;Text style={{ fontSize: 16, color: '#CBD5E1', lineHeight: 1.7 }}&gt;· 结构空间：圆形机身 + 集尘盒，天然容纳钻采 / 样本仓&lt;/Text&gt;&#10;          &lt;Text style={{ fontSize: 16, color: '#CBD5E1', lineHeight: 1.7 }}&gt;· 成本可控：消费底座约千元内，改装后价值跃升&lt;/Text&gt;&#10;          &lt;Text style={{ fontSize: 16, color: '#CBD5E1', lineHeight: 1.7 }}&gt;· 可验证：本地仿真即可闭环，无需先发射&lt;/Text&gt;&#10;        &lt;/Box&gt;&#10;      &lt;/Animation&gt;&#10;    &lt;/Box&gt;&#10;    &lt;Box style={{ width: '40%', height: '100%', justifyContent: 'center', padding: '0 40px', gap: 16 }}&gt;&#10;      &lt;Animation animType=&quot;fadeIn&quot; startType=&quot;afterPrevious&quot; duration={600}&gt;&#10;        &lt;Box style={{ background: '#0F1B33', border: '1px solid #1E3A5F', borderRadius: 12, padding: 20 }}&gt;&#10;          &lt;Text style={{ fontSize: 20, color: '#3B82F6', fontWeight: 'bold' }}&gt;成熟&lt;/Text&gt;&#10;          &lt;Text style={{ fontSize: 14, color: '#94A3B8', marginTop: 6, lineHeight: 1.6 }}&gt;量产地盘，可靠性已被市场验证&lt;/Text&gt;&#10;        &lt;/Box&gt;&#10;      &lt;/Animation&gt;&#10;      &lt;Animation animType=&quot;fadeIn&quot; startType=&quot;afterPrevious&quot; duration={600}&gt;&#10;        &lt;Box style={{ background: '#0F1B33', border: '1px solid #1E3A5F', borderRadius: 12, padding: 20 }}&gt;&#10;          &lt;Text style={{ fontSize: 20, color: '#22D3EE', fontWeight: 'bold' }}&gt;自主&lt;/Text&gt;&#10;          &lt;Text style={{ fontSize: 14, color: '#94A3B8', marginTop: 6, lineHeight: 1.6 }}&gt;自带 SLAM 与全覆盖算法内核&lt;/Text&gt;&#10;        &lt;/Box&gt;&#10;      &lt;/Animation&gt;&#10;      &lt;Animation animType=&quot;fadeIn&quot; startType=&quot;afterPrevious&quot; duration={600}&gt;&#10;        &lt;Box style={{ background: '#0F1B33', border: '1px solid #1E3A5F', borderRadius: 12, padding: 20 }}&gt;&#10;          &lt;Text style={{ fontSize: 20, color: '#F59E0B', fontWeight: 'bold' }}&gt;可改&lt;/Text&gt;&#10;          &lt;Text style={{ fontSize: 14, color: '#94A3B8', marginTop: 6, lineHeight: 1.6 }}&gt;集尘盒改造为集尘 / 样本双仓&lt;/Text&gt;&#10;        &lt;/Box&gt;&#10;      &lt;/Animation&gt;&#10;    &lt;/Box&gt;&#10;  &lt;/Box&gt;&#10;&lt;/Slide&gt;&#10;"/>
+        <p:cNvPr id="115" name="" descr="&lt;Slide type=&quot;content&quot;&gt;&#10;  &lt;Box style={{ width: '100%', height: '100%', background: '#0B1120', flexDirection: 'row' }}&gt;&#10;    &lt;Box style={{ width: '60%', height: '100%', justifyContent: 'center', padding: '0 56px', gap: 14 }}&gt;&#10;      &lt;Animation animType=&quot;fadeIn&quot; duration={600}&gt;&#10;        &lt;Text style={{ fontSize: 32, color: '#E5EDF7', fontWeight: 'bold' }}&gt;改装逻辑：为什么是扫地机器人&lt;/Text&gt;&#10;      &lt;/Animation&gt;&#10;      &lt;Animation animType=&quot;fadeIn&quot; startType=&quot;afterPrevious&quot; duration={600}&gt;&#10;        &lt;Text style={{ fontSize: 17, color: '#94A3B8', lineHeight: 1.8 }}&gt;&#10;          改装不是从零造机器人，而是「站在量产肩膀上」。消费级扫地机器人已经解决了最难的移动与自主问题，我们只需替换上身与作业模块，就能把清洁能力翻转成采矿能力。&#10;        &lt;/Text&gt;&#10;      &lt;/Animation&gt;&#10;      &lt;Animation animType=&quot;fadeIn&quot; startType=&quot;afterPrevious&quot; duration={600}&gt;&#10;        &lt;Box style={{ gap: 12, marginTop: 6 }}&gt;&#10;          &lt;Text style={{ fontSize: 16, color: '#CBD5E1', lineHeight: 1.7 }}&gt;· 成熟底盘：量产轮组 / 电池 / IMU，免从零研发&lt;/Text&gt;&#10;          &lt;Text style={{ fontSize: 16, color: '#CBD5E1', lineHeight: 1.7 }}&gt;· 自主导航：ROS2 + Nav2 全覆盖路径，直接复用&lt;/Text&gt;&#10;          &lt;Text style={{ fontSize: 16, color: '#CBD5E1', lineHeight: 1.7 }}&gt;· 结构空间：圆形机身 + 集尘盒，天然容纳钻采 / 样本仓&lt;/Text&gt;&#10;          &lt;Text style={{ fontSize: 16, color: '#CBD5E1', lineHeight: 1.7 }}&gt;· 成本可控：消费底座约千元内，改装后价值跃升&lt;/Text&gt;&#10;          &lt;Text style={{ fontSize: 16, color: '#CBD5E1', lineHeight: 1.7 }}&gt;· 可验证：本地仿真即可闭环，无需先发射&lt;/Text&gt;&#10;        &lt;/Box&gt;&#10;      &lt;/Animation&gt;&#10;    &lt;/Box&gt;&#10;    &lt;Box style={{ width: '40%', height: '100%', justifyContent: 'center', padding: '0 40px', gap: 16 }}&gt;&#10;      &lt;Animation animType=&quot;fadeIn&quot; startType=&quot;afterPrevious&quot; duration={600}&gt;&#10;        &lt;Box style={{ background: '#0F1B33', border: '1px solid #1E3A5F', borderRadius: 12, padding: 20 }}&gt;&#10;          &lt;Text style={{ fontSize: 20, color: '#3B82F6', fontWeight: 'bold' }}&gt;成熟&lt;/Text&gt;&#10;          &lt;Text style={{ fontSize: 14, color: '#94A3B8', marginTop: 6, lineHeight: 1.6 }}&gt;量产地盘，可靠性已被市场验证&lt;/Text&gt;&#10;        &lt;/Box&gt;&#10;      &lt;/Animation&gt;&#10;      &lt;Animation animType=&quot;fadeIn&quot; startType=&quot;afterPrevious&quot; duration={600}&gt;&#10;        &lt;Box style={{ background: '#0F1B33', border: '1px solid #1E3A5F', borderRadius: 12, padding: 20 }}&gt;&#10;          &lt;Text style={{ fontSize: 20, color: '#22D3EE', fontWeight: 'bold' }}&gt;自主&lt;/Text&gt;&#10;          &lt;Text style={{ fontSize: 14, color: '#94A3B8', marginTop: 6, lineHeight: 1.6 }}&gt;自带 SLAM 与全覆盖算法内核&lt;/Text&gt;&#10;        &lt;/Box&gt;&#10;      &lt;/Animation&gt;&#10;      &lt;Animation animType=&quot;fadeIn&quot; startType=&quot;afterPrevious&quot; duration={600}&gt;&#10;        &lt;Box style={{ background: '#0F1B33', border: '1px solid #1E3A5F', borderRadius: 12, padding: 20 }}&gt;&#10;          &lt;Text style={{ fontSize: 20, color: '#F59E0B', fontWeight: 'bold' }}&gt;可改&lt;/Text&gt;&#10;          &lt;Text style={{ fontSize: 14, color: '#94A3B8', marginTop: 6, lineHeight: 1.6 }}&gt;集尘盒改造为集尘 / 样本双仓&lt;/Text&gt;&#10;        &lt;/Box&gt;&#10;      &lt;/Animation&gt;&#10;    &lt;/Box&gt;&#10;  &lt;/Box&gt;&#10;&lt;/Slide&gt;&#10;"/>
         <p:cNvGrpSpPr/>
         <p:nvPr/>
       </p:nvGrpSpPr>
@@ -9578,7 +9668,7 @@
       </p:grpSpPr>
       <p:sp>
         <p:nvSpPr>
-          <p:cNvPr id="115" name=""/>
+          <p:cNvPr id="116" name=""/>
           <p:cNvSpPr/>
           <p:nvPr/>
         </p:nvSpPr>
@@ -9602,7 +9692,7 @@
       </p:sp>
       <p:sp>
         <p:nvSpPr>
-          <p:cNvPr id="116" name="" descr="{&quot;isTemplate&quot;:true,&quot;type&quot;:&quot;text&quot;}"/>
+          <p:cNvPr id="117" name="" descr="{&quot;isTemplate&quot;:true,&quot;type&quot;:&quot;text&quot;}"/>
           <p:cNvSpPr txBox="1"/>
           <p:nvPr/>
         </p:nvSpPr>
@@ -9637,7 +9727,7 @@
       </p:sp>
       <p:sp>
         <p:nvSpPr>
-          <p:cNvPr id="117" name="" descr="{&quot;isTemplate&quot;:true,&quot;type&quot;:&quot;text&quot;}"/>
+          <p:cNvPr id="118" name="" descr="{&quot;isTemplate&quot;:true,&quot;type&quot;:&quot;text&quot;}"/>
           <p:cNvSpPr txBox="1"/>
           <p:nvPr/>
         </p:nvSpPr>
@@ -9674,7 +9764,7 @@
       </p:sp>
       <p:sp>
         <p:nvSpPr>
-          <p:cNvPr id="118" name="" descr="{&quot;isTemplate&quot;:true,&quot;type&quot;:&quot;text&quot;}"/>
+          <p:cNvPr id="119" name="" descr="{&quot;isTemplate&quot;:true,&quot;type&quot;:&quot;text&quot;}"/>
           <p:cNvSpPr txBox="1"/>
           <p:nvPr/>
         </p:nvSpPr>
@@ -9759,7 +9849,7 @@
       </p:sp>
       <p:sp>
         <p:nvSpPr>
-          <p:cNvPr id="119" name="" descr="{&quot;isTemplate&quot;:true,&quot;type&quot;:&quot;text&quot;}"/>
+          <p:cNvPr id="120" name="" descr="{&quot;isTemplate&quot;:true,&quot;type&quot;:&quot;text&quot;}"/>
           <p:cNvSpPr txBox="1"/>
           <p:nvPr/>
         </p:nvSpPr>
@@ -9824,7 +9914,7 @@
       </p:sp>
       <p:sp>
         <p:nvSpPr>
-          <p:cNvPr id="120" name="" descr="{&quot;isTemplate&quot;:true,&quot;type&quot;:&quot;text&quot;}"/>
+          <p:cNvPr id="121" name="" descr="{&quot;isTemplate&quot;:true,&quot;type&quot;:&quot;text&quot;}"/>
           <p:cNvSpPr txBox="1"/>
           <p:nvPr/>
         </p:nvSpPr>
@@ -9909,7 +9999,7 @@
       </p:sp>
       <p:sp>
         <p:nvSpPr>
-          <p:cNvPr id="121" name="" descr="{&quot;isTemplate&quot;:true,&quot;type&quot;:&quot;text&quot;}"/>
+          <p:cNvPr id="122" name="" descr="{&quot;isTemplate&quot;:true,&quot;type&quot;:&quot;text&quot;}"/>
           <p:cNvSpPr txBox="1"/>
           <p:nvPr/>
         </p:nvSpPr>
@@ -9954,7 +10044,7 @@
       </p:sp>
       <p:sp>
         <p:nvSpPr>
-          <p:cNvPr id="122" name="" descr="{&quot;isTemplate&quot;:true,&quot;type&quot;:&quot;text&quot;}"/>
+          <p:cNvPr id="123" name="" descr="{&quot;isTemplate&quot;:true,&quot;type&quot;:&quot;text&quot;}"/>
           <p:cNvSpPr txBox="1"/>
           <p:nvPr/>
         </p:nvSpPr>
@@ -9999,7 +10089,7 @@
       </p:sp>
       <p:sp>
         <p:nvSpPr>
-          <p:cNvPr id="123" name=""/>
+          <p:cNvPr id="124" name=""/>
           <p:cNvSpPr/>
           <p:nvPr/>
         </p:nvSpPr>
@@ -10030,7 +10120,7 @@
       </p:sp>
       <p:sp>
         <p:nvSpPr>
-          <p:cNvPr id="124" name="" descr="{&quot;isTemplate&quot;:true,&quot;type&quot;:&quot;text&quot;}"/>
+          <p:cNvPr id="125" name="" descr="{&quot;isTemplate&quot;:true,&quot;type&quot;:&quot;text&quot;}"/>
           <p:cNvSpPr txBox="1"/>
           <p:nvPr/>
         </p:nvSpPr>
@@ -10065,7 +10155,7 @@
       </p:sp>
       <p:sp>
         <p:nvSpPr>
-          <p:cNvPr id="125" name="" descr="{&quot;isTemplate&quot;:true,&quot;type&quot;:&quot;text&quot;}"/>
+          <p:cNvPr id="126" name="" descr="{&quot;isTemplate&quot;:true,&quot;type&quot;:&quot;text&quot;}"/>
           <p:cNvSpPr txBox="1"/>
           <p:nvPr/>
         </p:nvSpPr>
@@ -10100,7 +10190,7 @@
       </p:sp>
       <p:sp>
         <p:nvSpPr>
-          <p:cNvPr id="126" name=""/>
+          <p:cNvPr id="127" name=""/>
           <p:cNvSpPr/>
           <p:nvPr/>
         </p:nvSpPr>
@@ -10131,7 +10221,7 @@
       </p:sp>
       <p:sp>
         <p:nvSpPr>
-          <p:cNvPr id="127" name="" descr="{&quot;isTemplate&quot;:true,&quot;type&quot;:&quot;text&quot;}"/>
+          <p:cNvPr id="128" name="" descr="{&quot;isTemplate&quot;:true,&quot;type&quot;:&quot;text&quot;}"/>
           <p:cNvSpPr txBox="1"/>
           <p:nvPr/>
         </p:nvSpPr>
@@ -10166,7 +10256,7 @@
       </p:sp>
       <p:sp>
         <p:nvSpPr>
-          <p:cNvPr id="128" name="" descr="{&quot;isTemplate&quot;:true,&quot;type&quot;:&quot;text&quot;}"/>
+          <p:cNvPr id="129" name="" descr="{&quot;isTemplate&quot;:true,&quot;type&quot;:&quot;text&quot;}"/>
           <p:cNvSpPr txBox="1"/>
           <p:nvPr/>
         </p:nvSpPr>
@@ -10221,7 +10311,7 @@
       </p:sp>
       <p:sp>
         <p:nvSpPr>
-          <p:cNvPr id="129" name=""/>
+          <p:cNvPr id="130" name=""/>
           <p:cNvSpPr/>
           <p:nvPr/>
         </p:nvSpPr>
@@ -10252,7 +10342,7 @@
       </p:sp>
       <p:sp>
         <p:nvSpPr>
-          <p:cNvPr id="130" name="" descr="{&quot;isTemplate&quot;:true,&quot;type&quot;:&quot;text&quot;}"/>
+          <p:cNvPr id="131" name="" descr="{&quot;isTemplate&quot;:true,&quot;type&quot;:&quot;text&quot;}"/>
           <p:cNvSpPr txBox="1"/>
           <p:nvPr/>
         </p:nvSpPr>
@@ -10287,7 +10377,7 @@
       </p:sp>
       <p:sp>
         <p:nvSpPr>
-          <p:cNvPr id="131" name="" descr="{&quot;isTemplate&quot;:true,&quot;type&quot;:&quot;text&quot;}"/>
+          <p:cNvPr id="132" name="" descr="{&quot;isTemplate&quot;:true,&quot;type&quot;:&quot;text&quot;}"/>
           <p:cNvSpPr txBox="1"/>
           <p:nvPr/>
         </p:nvSpPr>
@@ -10363,20 +10453,20 @@
                             </p:stCondLst>
                             <p:childTnLst>
                               <p:par>
-                                <p:cTn id="229" presetID="10" presetClass="entr" presetSubtype="0" fill="hold" grpId="0" nodeType="withEffect">
+                                <p:cTn id="232" presetID="10" presetClass="entr" presetSubtype="0" fill="hold" grpId="0" nodeType="withEffect">
                                   <p:stCondLst>
                                     <p:cond delay="0"/>
                                   </p:stCondLst>
                                   <p:childTnLst>
                                     <p:set>
                                       <p:cBhvr>
-                                        <p:cTn id="230" dur="1" fill="hold">
+                                        <p:cTn id="233" dur="1" fill="hold">
                                           <p:stCondLst>
                                             <p:cond delay="0"/>
                                           </p:stCondLst>
                                         </p:cTn>
                                         <p:tgtEl>
-                                          <p:spTgt spid="116"/>
+                                          <p:spTgt spid="117"/>
                                         </p:tgtEl>
                                         <p:attrNameLst>
                                           <p:attrName>style.visibility</p:attrName>
@@ -10388,44 +10478,9 @@
                                     </p:set>
                                     <p:animEffect transition="in" filter="fade">
                                       <p:cBhvr>
-                                        <p:cTn id="231" dur="600"/>
-                                        <p:tgtEl>
-                                          <p:spTgt spid="116"/>
-                                        </p:tgtEl>
-                                      </p:cBhvr>
-                                    </p:animEffect>
-                                  </p:childTnLst>
-                                </p:cTn>
-                              </p:par>
-                              <p:par>
-                                <p:cTn id="232" presetID="10" presetClass="entr" presetSubtype="0" fill="hold" grpId="2" nodeType="withEffect">
-                                  <p:stCondLst>
-                                    <p:cond delay="0"/>
-                                  </p:stCondLst>
-                                  <p:childTnLst>
-                                    <p:set>
-                                      <p:cBhvr>
-                                        <p:cTn id="233" dur="1" fill="hold">
-                                          <p:stCondLst>
-                                            <p:cond delay="0"/>
-                                          </p:stCondLst>
-                                        </p:cTn>
-                                        <p:tgtEl>
-                                          <p:spTgt spid="119"/>
-                                        </p:tgtEl>
-                                        <p:attrNameLst>
-                                          <p:attrName>style.visibility</p:attrName>
-                                        </p:attrNameLst>
-                                      </p:cBhvr>
-                                      <p:to>
-                                        <p:strVal val="visible"/>
-                                      </p:to>
-                                    </p:set>
-                                    <p:animEffect transition="in" filter="fade">
-                                      <p:cBhvr>
                                         <p:cTn id="234" dur="600"/>
                                         <p:tgtEl>
-                                          <p:spTgt spid="119"/>
+                                          <p:spTgt spid="117"/>
                                         </p:tgtEl>
                                       </p:cBhvr>
                                     </p:animEffect>
@@ -10538,7 +10593,7 @@
                                 </p:cTn>
                               </p:par>
                               <p:par>
-                                <p:cTn id="244" presetID="10" presetClass="entr" presetSubtype="0" fill="hold" grpId="3" nodeType="withEffect">
+                                <p:cTn id="244" presetID="10" presetClass="entr" presetSubtype="0" fill="hold" grpId="2" nodeType="withEffect">
                                   <p:stCondLst>
                                     <p:cond delay="0"/>
                                   </p:stCondLst>
@@ -10551,7 +10606,7 @@
                                           </p:stCondLst>
                                         </p:cTn>
                                         <p:tgtEl>
-                                          <p:spTgt spid="124"/>
+                                          <p:spTgt spid="123"/>
                                         </p:tgtEl>
                                         <p:attrNameLst>
                                           <p:attrName>style.visibility</p:attrName>
@@ -10565,7 +10620,7 @@
                                       <p:cBhvr>
                                         <p:cTn id="246" dur="600"/>
                                         <p:tgtEl>
-                                          <p:spTgt spid="124"/>
+                                          <p:spTgt spid="123"/>
                                         </p:tgtEl>
                                       </p:cBhvr>
                                     </p:animEffect>
@@ -10608,7 +10663,7 @@
                                 </p:cTn>
                               </p:par>
                               <p:par>
-                                <p:cTn id="250" presetID="10" presetClass="entr" presetSubtype="0" fill="hold" grpId="4" nodeType="withEffect">
+                                <p:cTn id="250" presetID="10" presetClass="entr" presetSubtype="0" fill="hold" grpId="3" nodeType="withEffect">
                                   <p:stCondLst>
                                     <p:cond delay="0"/>
                                   </p:stCondLst>
@@ -10621,7 +10676,7 @@
                                           </p:stCondLst>
                                         </p:cTn>
                                         <p:tgtEl>
-                                          <p:spTgt spid="127"/>
+                                          <p:spTgt spid="126"/>
                                         </p:tgtEl>
                                         <p:attrNameLst>
                                           <p:attrName>style.visibility</p:attrName>
@@ -10635,7 +10690,7 @@
                                       <p:cBhvr>
                                         <p:cTn id="252" dur="600"/>
                                         <p:tgtEl>
-                                          <p:spTgt spid="127"/>
+                                          <p:spTgt spid="126"/>
                                         </p:tgtEl>
                                       </p:cBhvr>
                                     </p:animEffect>
@@ -10678,7 +10733,7 @@
                                 </p:cTn>
                               </p:par>
                               <p:par>
-                                <p:cTn id="256" presetID="10" presetClass="entr" presetSubtype="0" fill="hold" grpId="5" nodeType="withEffect">
+                                <p:cTn id="256" presetID="10" presetClass="entr" presetSubtype="0" fill="hold" grpId="4" nodeType="withEffect">
                                   <p:stCondLst>
                                     <p:cond delay="0"/>
                                   </p:stCondLst>
@@ -10691,7 +10746,7 @@
                                           </p:stCondLst>
                                         </p:cTn>
                                         <p:tgtEl>
-                                          <p:spTgt spid="130"/>
+                                          <p:spTgt spid="129"/>
                                         </p:tgtEl>
                                         <p:attrNameLst>
                                           <p:attrName>style.visibility</p:attrName>
@@ -10705,7 +10760,7 @@
                                       <p:cBhvr>
                                         <p:cTn id="258" dur="600"/>
                                         <p:tgtEl>
-                                          <p:spTgt spid="130"/>
+                                          <p:spTgt spid="129"/>
                                         </p:tgtEl>
                                       </p:cBhvr>
                                     </p:animEffect>
@@ -10741,6 +10796,41 @@
                                         <p:cTn id="261" dur="600"/>
                                         <p:tgtEl>
                                           <p:spTgt spid="131"/>
+                                        </p:tgtEl>
+                                      </p:cBhvr>
+                                    </p:animEffect>
+                                  </p:childTnLst>
+                                </p:cTn>
+                              </p:par>
+                              <p:par>
+                                <p:cTn id="262" presetID="10" presetClass="entr" presetSubtype="0" fill="hold" grpId="5" nodeType="withEffect">
+                                  <p:stCondLst>
+                                    <p:cond delay="0"/>
+                                  </p:stCondLst>
+                                  <p:childTnLst>
+                                    <p:set>
+                                      <p:cBhvr>
+                                        <p:cTn id="263" dur="1" fill="hold">
+                                          <p:stCondLst>
+                                            <p:cond delay="0"/>
+                                          </p:stCondLst>
+                                        </p:cTn>
+                                        <p:tgtEl>
+                                          <p:spTgt spid="132"/>
+                                        </p:tgtEl>
+                                        <p:attrNameLst>
+                                          <p:attrName>style.visibility</p:attrName>
+                                        </p:attrNameLst>
+                                      </p:cBhvr>
+                                      <p:to>
+                                        <p:strVal val="visible"/>
+                                      </p:to>
+                                    </p:set>
+                                    <p:animEffect transition="in" filter="fade">
+                                      <p:cBhvr>
+                                        <p:cTn id="264" dur="600"/>
+                                        <p:tgtEl>
+                                          <p:spTgt spid="132"/>
                                         </p:tgtEl>
                                       </p:cBhvr>
                                     </p:animEffect>
@@ -10757,20 +10847,20 @@
                             </p:stCondLst>
                             <p:childTnLst>
                               <p:par>
-                                <p:cTn id="262" presetID="10" presetClass="entr" presetSubtype="0" fill="hold" grpId="1" nodeType="afterEffect">
+                                <p:cTn id="265" presetID="10" presetClass="entr" presetSubtype="0" fill="hold" grpId="1" nodeType="afterEffect">
                                   <p:stCondLst>
                                     <p:cond delay="0"/>
                                   </p:stCondLst>
                                   <p:childTnLst>
                                     <p:set>
                                       <p:cBhvr>
-                                        <p:cTn id="263" dur="1" fill="hold">
+                                        <p:cTn id="266" dur="1" fill="hold">
                                           <p:stCondLst>
                                             <p:cond delay="0"/>
                                           </p:stCondLst>
                                         </p:cTn>
                                         <p:tgtEl>
-                                          <p:spTgt spid="117"/>
+                                          <p:spTgt spid="118"/>
                                         </p:tgtEl>
                                         <p:attrNameLst>
                                           <p:attrName>style.visibility</p:attrName>
@@ -10782,9 +10872,9 @@
                                     </p:set>
                                     <p:animEffect transition="in" filter="fade">
                                       <p:cBhvr>
-                                        <p:cTn id="264" dur="600"/>
-                                        <p:tgtEl>
-                                          <p:spTgt spid="117"/>
+                                        <p:cTn id="267" dur="600"/>
+                                        <p:tgtEl>
+                                          <p:spTgt spid="118"/>
                                         </p:tgtEl>
                                       </p:cBhvr>
                                     </p:animEffect>
@@ -10801,20 +10891,20 @@
                             </p:stCondLst>
                             <p:childTnLst>
                               <p:par>
-                                <p:cTn id="265" presetID="10" presetClass="entr" presetSubtype="0" fill="hold" grpId="2" nodeType="afterEffect">
+                                <p:cTn id="268" presetID="10" presetClass="entr" presetSubtype="0" fill="hold" grpId="2" nodeType="afterEffect">
                                   <p:stCondLst>
                                     <p:cond delay="0"/>
                                   </p:stCondLst>
                                   <p:childTnLst>
                                     <p:set>
                                       <p:cBhvr>
-                                        <p:cTn id="266" dur="1" fill="hold">
+                                        <p:cTn id="269" dur="1" fill="hold">
                                           <p:stCondLst>
                                             <p:cond delay="0"/>
                                           </p:stCondLst>
                                         </p:cTn>
                                         <p:tgtEl>
-                                          <p:spTgt spid="118"/>
+                                          <p:spTgt spid="119"/>
                                         </p:tgtEl>
                                         <p:attrNameLst>
                                           <p:attrName>style.visibility</p:attrName>
@@ -10826,9 +10916,9 @@
                                     </p:set>
                                     <p:animEffect transition="in" filter="fade">
                                       <p:cBhvr>
-                                        <p:cTn id="267" dur="600"/>
-                                        <p:tgtEl>
-                                          <p:spTgt spid="118"/>
+                                        <p:cTn id="270" dur="600"/>
+                                        <p:tgtEl>
+                                          <p:spTgt spid="119"/>
                                         </p:tgtEl>
                                       </p:cBhvr>
                                     </p:animEffect>
@@ -10845,20 +10935,20 @@
                             </p:stCondLst>
                             <p:childTnLst>
                               <p:par>
-                                <p:cTn id="268" presetID="10" presetClass="entr" presetSubtype="0" fill="hold" grpId="3" nodeType="afterEffect">
+                                <p:cTn id="271" presetID="10" presetClass="entr" presetSubtype="0" fill="hold" grpId="3" nodeType="afterEffect">
                                   <p:stCondLst>
                                     <p:cond delay="0"/>
                                   </p:stCondLst>
                                   <p:childTnLst>
                                     <p:set>
                                       <p:cBhvr>
-                                        <p:cTn id="269" dur="1" fill="hold">
+                                        <p:cTn id="272" dur="1" fill="hold">
                                           <p:stCondLst>
                                             <p:cond delay="0"/>
                                           </p:stCondLst>
                                         </p:cTn>
                                         <p:tgtEl>
-                                          <p:spTgt spid="123"/>
+                                          <p:spTgt spid="124"/>
                                         </p:tgtEl>
                                         <p:attrNameLst>
                                           <p:attrName>style.visibility</p:attrName>
@@ -10870,9 +10960,9 @@
                                     </p:set>
                                     <p:animEffect transition="in" filter="fade">
                                       <p:cBhvr>
-                                        <p:cTn id="270" dur="600"/>
-                                        <p:tgtEl>
-                                          <p:spTgt spid="123"/>
+                                        <p:cTn id="273" dur="600"/>
+                                        <p:tgtEl>
+                                          <p:spTgt spid="124"/>
                                         </p:tgtEl>
                                       </p:cBhvr>
                                     </p:animEffect>
@@ -10889,20 +10979,20 @@
                             </p:stCondLst>
                             <p:childTnLst>
                               <p:par>
-                                <p:cTn id="271" presetID="10" presetClass="entr" presetSubtype="0" fill="hold" grpId="4" nodeType="afterEffect">
+                                <p:cTn id="274" presetID="10" presetClass="entr" presetSubtype="0" fill="hold" grpId="4" nodeType="afterEffect">
                                   <p:stCondLst>
                                     <p:cond delay="0"/>
                                   </p:stCondLst>
                                   <p:childTnLst>
                                     <p:set>
                                       <p:cBhvr>
-                                        <p:cTn id="272" dur="1" fill="hold">
+                                        <p:cTn id="275" dur="1" fill="hold">
                                           <p:stCondLst>
                                             <p:cond delay="0"/>
                                           </p:stCondLst>
                                         </p:cTn>
                                         <p:tgtEl>
-                                          <p:spTgt spid="126"/>
+                                          <p:spTgt spid="127"/>
                                         </p:tgtEl>
                                         <p:attrNameLst>
                                           <p:attrName>style.visibility</p:attrName>
@@ -10914,9 +11004,9 @@
                                     </p:set>
                                     <p:animEffect transition="in" filter="fade">
                                       <p:cBhvr>
-                                        <p:cTn id="273" dur="600"/>
-                                        <p:tgtEl>
-                                          <p:spTgt spid="126"/>
+                                        <p:cTn id="276" dur="600"/>
+                                        <p:tgtEl>
+                                          <p:spTgt spid="127"/>
                                         </p:tgtEl>
                                       </p:cBhvr>
                                     </p:animEffect>
@@ -10933,20 +11023,20 @@
                             </p:stCondLst>
                             <p:childTnLst>
                               <p:par>
-                                <p:cTn id="274" presetID="10" presetClass="entr" presetSubtype="0" fill="hold" grpId="5" nodeType="afterEffect">
+                                <p:cTn id="277" presetID="10" presetClass="entr" presetSubtype="0" fill="hold" grpId="5" nodeType="afterEffect">
                                   <p:stCondLst>
                                     <p:cond delay="0"/>
                                   </p:stCondLst>
                                   <p:childTnLst>
                                     <p:set>
                                       <p:cBhvr>
-                                        <p:cTn id="275" dur="1" fill="hold">
+                                        <p:cTn id="278" dur="1" fill="hold">
                                           <p:stCondLst>
                                             <p:cond delay="0"/>
                                           </p:stCondLst>
                                         </p:cTn>
                                         <p:tgtEl>
-                                          <p:spTgt spid="129"/>
+                                          <p:spTgt spid="130"/>
                                         </p:tgtEl>
                                         <p:attrNameLst>
                                           <p:attrName>style.visibility</p:attrName>
@@ -10958,9 +11048,9 @@
                                     </p:set>
                                     <p:animEffect transition="in" filter="fade">
                                       <p:cBhvr>
-                                        <p:cTn id="276" dur="600"/>
-                                        <p:tgtEl>
-                                          <p:spTgt spid="129"/>
+                                        <p:cTn id="279" dur="600"/>
+                                        <p:tgtEl>
+                                          <p:spTgt spid="130"/>
                                         </p:tgtEl>
                                       </p:cBhvr>
                                     </p:animEffect>
@@ -10999,7 +11089,7 @@
   <p:cSld>
     <p:spTree>
       <p:nvGrpSpPr>
-        <p:cNvPr id="132" name="" descr="&lt;Slide type=&quot;section&quot;&gt;&#10;  &lt;Box style={{ position: 'relative', width: '100%', height: '100%', background: '#0B1120' }}&gt;&#10;    &lt;Image src=&quot;assets/cmr_structure.svg&quot; style={{ position: 'absolute', top: 0, left: 0, width: '100%', height: '100%', objectFit: 'cover', opacity: 0.4 }} /&gt;&#10;    &lt;Box style={{ position: 'absolute', top: 0, left: 0, width: '100%', height: '100%', background: 'linear-gradient(120deg, rgba(11,17,32,0.9) 0%, rgba(11,17,32,0.5) 100%)' }} /&gt;&#10;    &lt;Box style={{ position: 'relative', zIndex: 2, height: '100%', justifyContent: 'center', padding: '0 96px' }}&gt;&#10;      &lt;Animation animType=&quot;fadeIn&quot; duration={700}&gt;&#10;        &lt;Text style={{ fontSize: 34, color: '#22D3EE', fontWeight: 'bold', letterSpacing: 4 }}&gt;CHAPTER 02&lt;/Text&gt;&#10;      &lt;/Animation&gt;&#10;      &lt;Animation animType=&quot;fadeIn&quot; startType=&quot;afterPrevious&quot; duration={700}&gt;&#10;        &lt;Text style={{ fontSize: 60, color: '#E5EDF7', fontWeight: 'bold', marginTop: 16 }}&gt;机器结构与抗辐射芯片&lt;/Text&gt;&#10;      &lt;/Animation&gt;&#10;      &lt;Animation animType=&quot;fadeIn&quot; startType=&quot;afterPrevious&quot; duration={700}&gt;&#10;        &lt;Text style={{ fontSize: 22, color: '#94A3B8', marginTop: 22 }}&gt;316L 不锈钢机身 · 扫地机器人底座 · 西电第三代半导体&lt;/Text&gt;&#10;      &lt;/Animation&gt;&#10;    &lt;/Box&gt;&#10;  &lt;/Box&gt;&#10;&lt;/Slide&gt;&#10;"/>
+        <p:cNvPr id="133" name="" descr="&lt;Slide type=&quot;section&quot;&gt;&#10;  &lt;Box style={{ position: 'relative', width: '100%', height: '100%', background: '#0B1120' }}&gt;&#10;    &lt;Image src=&quot;assets/cmr_structure.svg&quot; style={{ position: 'absolute', top: 0, left: 0, width: '100%', height: '100%', objectFit: 'cover', opacity: 0.4 }} /&gt;&#10;    &lt;Box style={{ position: 'absolute', top: 0, left: 0, width: '100%', height: '100%', background: 'linear-gradient(120deg, rgba(11,17,32,0.9) 0%, rgba(11,17,32,0.5) 100%)' }} /&gt;&#10;    &lt;Box style={{ position: 'relative', zIndex: 2, height: '100%', justifyContent: 'center', padding: '0 96px' }}&gt;&#10;      &lt;Animation animType=&quot;fadeIn&quot; duration={700}&gt;&#10;        &lt;Text style={{ fontSize: 34, color: '#22D3EE', fontWeight: 'bold', letterSpacing: 4 }}&gt;CHAPTER 02&lt;/Text&gt;&#10;      &lt;/Animation&gt;&#10;      &lt;Animation animType=&quot;fadeIn&quot; startType=&quot;afterPrevious&quot; duration={700}&gt;&#10;        &lt;Text style={{ fontSize: 60, color: '#E5EDF7', fontWeight: 'bold', marginTop: 16 }}&gt;机器结构与抗辐射芯片&lt;/Text&gt;&#10;      &lt;/Animation&gt;&#10;      &lt;Animation animType=&quot;fadeIn&quot; startType=&quot;afterPrevious&quot; duration={700}&gt;&#10;        &lt;Text style={{ fontSize: 22, color: '#94A3B8', marginTop: 22 }}&gt;316L 不锈钢机身 · 扫地机器人底座 · 西电第三代半导体&lt;/Text&gt;&#10;      &lt;/Animation&gt;&#10;    &lt;/Box&gt;&#10;  &lt;/Box&gt;&#10;&lt;/Slide&gt;&#10;"/>
         <p:cNvGrpSpPr/>
         <p:nvPr/>
       </p:nvGrpSpPr>
@@ -11013,7 +11103,7 @@
       </p:grpSpPr>
       <p:sp>
         <p:nvSpPr>
-          <p:cNvPr id="133" name=""/>
+          <p:cNvPr id="134" name=""/>
           <p:cNvSpPr/>
           <p:nvPr/>
         </p:nvSpPr>
@@ -11037,7 +11127,7 @@
       </p:sp>
       <p:pic>
         <p:nvPicPr>
-          <p:cNvPr id="134" name=""/>
+          <p:cNvPr id="135" name=""/>
           <p:cNvPicPr>
             <a:picLocks noChangeAspect="1"/>
           </p:cNvPicPr>
@@ -11070,7 +11160,7 @@
       </p:pic>
       <p:sp>
         <p:nvSpPr>
-          <p:cNvPr id="135" name=""/>
+          <p:cNvPr id="136" name=""/>
           <p:cNvSpPr/>
           <p:nvPr/>
         </p:nvSpPr>
@@ -11106,7 +11196,7 @@
       </p:sp>
       <p:sp>
         <p:nvSpPr>
-          <p:cNvPr id="136" name="" descr="{&quot;isTemplate&quot;:true,&quot;type&quot;:&quot;text&quot;}"/>
+          <p:cNvPr id="137" name="" descr="{&quot;isTemplate&quot;:true,&quot;type&quot;:&quot;text&quot;}"/>
           <p:cNvSpPr txBox="1"/>
           <p:nvPr/>
         </p:nvSpPr>
@@ -11141,7 +11231,7 @@
       </p:sp>
       <p:sp>
         <p:nvSpPr>
-          <p:cNvPr id="137" name="" descr="{&quot;isTemplate&quot;:true,&quot;type&quot;:&quot;text&quot;}"/>
+          <p:cNvPr id="138" name="" descr="{&quot;isTemplate&quot;:true,&quot;type&quot;:&quot;text&quot;}"/>
           <p:cNvSpPr txBox="1"/>
           <p:nvPr/>
         </p:nvSpPr>
@@ -11176,7 +11266,7 @@
       </p:sp>
       <p:sp>
         <p:nvSpPr>
-          <p:cNvPr id="138" name="" descr="{&quot;isTemplate&quot;:true,&quot;type&quot;:&quot;text&quot;}"/>
+          <p:cNvPr id="139" name="" descr="{&quot;isTemplate&quot;:true,&quot;type&quot;:&quot;text&quot;}"/>
           <p:cNvSpPr txBox="1"/>
           <p:nvPr/>
         </p:nvSpPr>
@@ -11282,20 +11372,20 @@
                             </p:stCondLst>
                             <p:childTnLst>
                               <p:par>
-                                <p:cTn id="277" presetID="10" presetClass="entr" presetSubtype="0" fill="hold" grpId="0" nodeType="withEffect">
+                                <p:cTn id="280" presetID="10" presetClass="entr" presetSubtype="0" fill="hold" grpId="0" nodeType="withEffect">
                                   <p:stCondLst>
                                     <p:cond delay="0"/>
                                   </p:stCondLst>
                                   <p:childTnLst>
                                     <p:set>
                                       <p:cBhvr>
-                                        <p:cTn id="278" dur="1" fill="hold">
+                                        <p:cTn id="281" dur="1" fill="hold">
                                           <p:stCondLst>
                                             <p:cond delay="0"/>
                                           </p:stCondLst>
                                         </p:cTn>
                                         <p:tgtEl>
-                                          <p:spTgt spid="136"/>
+                                          <p:spTgt spid="137"/>
                                         </p:tgtEl>
                                         <p:attrNameLst>
                                           <p:attrName>style.visibility</p:attrName>
@@ -11307,9 +11397,9 @@
                                     </p:set>
                                     <p:animEffect transition="in" filter="fade">
                                       <p:cBhvr>
-                                        <p:cTn id="279" dur="700"/>
-                                        <p:tgtEl>
-                                          <p:spTgt spid="136"/>
+                                        <p:cTn id="282" dur="700"/>
+                                        <p:tgtEl>
+                                          <p:spTgt spid="137"/>
                                         </p:tgtEl>
                                       </p:cBhvr>
                                     </p:animEffect>
@@ -11326,20 +11416,20 @@
                             </p:stCondLst>
                             <p:childTnLst>
                               <p:par>
-                                <p:cTn id="280" presetID="10" presetClass="entr" presetSubtype="0" fill="hold" grpId="1" nodeType="afterEffect">
+                                <p:cTn id="283" presetID="10" presetClass="entr" presetSubtype="0" fill="hold" grpId="1" nodeType="afterEffect">
                                   <p:stCondLst>
                                     <p:cond delay="0"/>
                                   </p:stCondLst>
                                   <p:childTnLst>
                                     <p:set>
                                       <p:cBhvr>
-                                        <p:cTn id="281" dur="1" fill="hold">
+                                        <p:cTn id="284" dur="1" fill="hold">
                                           <p:stCondLst>
                                             <p:cond delay="0"/>
                                           </p:stCondLst>
                                         </p:cTn>
                                         <p:tgtEl>
-                                          <p:spTgt spid="137"/>
+                                          <p:spTgt spid="138"/>
                                         </p:tgtEl>
                                         <p:attrNameLst>
                                           <p:attrName>style.visibility</p:attrName>
@@ -11351,9 +11441,9 @@
                                     </p:set>
                                     <p:animEffect transition="in" filter="fade">
                                       <p:cBhvr>
-                                        <p:cTn id="282" dur="700"/>
-                                        <p:tgtEl>
-                                          <p:spTgt spid="137"/>
+                                        <p:cTn id="285" dur="700"/>
+                                        <p:tgtEl>
+                                          <p:spTgt spid="138"/>
                                         </p:tgtEl>
                                       </p:cBhvr>
                                     </p:animEffect>
@@ -11370,20 +11460,20 @@
                             </p:stCondLst>
                             <p:childTnLst>
                               <p:par>
-                                <p:cTn id="283" presetID="10" presetClass="entr" presetSubtype="0" fill="hold" grpId="2" nodeType="afterEffect">
+                                <p:cTn id="286" presetID="10" presetClass="entr" presetSubtype="0" fill="hold" grpId="2" nodeType="afterEffect">
                                   <p:stCondLst>
                                     <p:cond delay="0"/>
                                   </p:stCondLst>
                                   <p:childTnLst>
                                     <p:set>
                                       <p:cBhvr>
-                                        <p:cTn id="284" dur="1" fill="hold">
+                                        <p:cTn id="287" dur="1" fill="hold">
                                           <p:stCondLst>
                                             <p:cond delay="0"/>
                                           </p:stCondLst>
                                         </p:cTn>
                                         <p:tgtEl>
-                                          <p:spTgt spid="138"/>
+                                          <p:spTgt spid="139"/>
                                         </p:tgtEl>
                                         <p:attrNameLst>
                                           <p:attrName>style.visibility</p:attrName>
@@ -11395,9 +11485,9 @@
                                     </p:set>
                                     <p:animEffect transition="in" filter="fade">
                                       <p:cBhvr>
-                                        <p:cTn id="285" dur="700"/>
-                                        <p:tgtEl>
-                                          <p:spTgt spid="138"/>
+                                        <p:cTn id="288" dur="700"/>
+                                        <p:tgtEl>
+                                          <p:spTgt spid="139"/>
                                         </p:tgtEl>
                                       </p:cBhvr>
                                     </p:animEffect>
@@ -11436,7 +11526,7 @@
   <p:cSld>
     <p:spTree>
       <p:nvGrpSpPr>
-        <p:cNvPr id="139" name="" descr="&lt;Slide type=&quot;content&quot;&gt;&#10;  &lt;Box style={{ width: '100%', height: '100%', background: '#0B1120', flexDirection: 'row' }}&gt;&#10;    &lt;Box style={{ width: '55%', height: '100%', justifyContent: 'center', alignItems: 'center', padding: '40px' }}&gt;&#10;      &lt;Image src=&quot;assets/robo_base.svg&quot; style={{ width: '100%', height: '100%', objectFit: 'contain' }} /&gt;&#10;    &lt;/Box&gt;&#10;    &lt;Box style={{ flex: 1, justifyContent: 'center', padding: '0 52px', gap: 14 }}&gt;&#10;      &lt;Animation animType=&quot;fadeIn&quot; duration={600}&gt;&#10;        &lt;Text style={{ fontSize: 32, color: '#E5EDF7', fontWeight: 'bold' }}&gt;扫地机器人底座结构&lt;/Text&gt;&#10;      &lt;/Animation&gt;&#10;      &lt;Animation animType=&quot;fadeIn&quot; startType=&quot;afterPrevious&quot; duration={600}&gt;&#10;        &lt;Text style={{ fontSize: 16, color: '#94A3B8', lineHeight: 1.8 }}&gt;爆炸视图自底向上六层，是整台 CMR 的「腿」与「神经」。改装只动上身，底盘全部保留。&lt;/Text&gt;&#10;      &lt;/Animation&gt;&#10;      &lt;Animation animType=&quot;fadeIn&quot; startType=&quot;afterPrevious&quot; duration={600}&gt;&#10;        &lt;Box style={{ gap: 10, marginTop: 4 }}&gt;&#10;          &lt;Box style={{ flexDirection: 'row', gap: 12, alignItems: 'center' }}&gt;&lt;Text style={{ fontSize: 15, color: '#22D3EE', fontWeight: 'bold', width: 90 }}&gt;底盘轮组&lt;/Text&gt;&lt;Text style={{ fontSize: 15, color: '#CBD5E1' }}&gt;差速 / 全向轮，适应地外起伏地形&lt;/Text&gt;&lt;/Box&gt;&#10;          &lt;Box style={{ flexDirection: 'row', gap: 12, alignItems: 'center' }}&gt;&lt;Text style={{ fontSize: 15, color: '#22D3EE', fontWeight: 'bold', width: 90 }}&gt;电源&lt;/Text&gt;&lt;Text style={{ fontSize: 15, color: '#CBD5E1' }}&gt;锂电池 + 太阳能板（西电 SiC MPPT）&lt;/Text&gt;&lt;/Box&gt;&#10;          &lt;Box style={{ flexDirection: 'row', gap: 12, alignItems: 'center' }}&gt;&lt;Text style={{ fontSize: 15, color: '#22D3EE', fontWeight: 'bold', width: 90 }}&gt;感知&lt;/Text&gt;&lt;Text style={{ fontSize: 15, color: '#CBD5E1' }}&gt;LiDAR + 视觉 SLAM 传感器&lt;/Text&gt;&lt;/Box&gt;&#10;          &lt;Box style={{ flexDirection: 'row', gap: 12, alignItems: 'center' }}&gt;&lt;Text style={{ fontSize: 15, color: '#22D3EE', fontWeight: 'bold', width: 90 }}&gt;控制&lt;/Text&gt;&lt;Text style={{ fontSize: 15, color: '#CBD5E1' }}&gt;ROS2 边缘主控制器&lt;/Text&gt;&lt;/Box&gt;&#10;          &lt;Box style={{ flexDirection: 'row', gap: 12, alignItems: 'center' }}&gt;&lt;Text style={{ fontSize: 15, color: '#22D3EE', fontWeight: 'bold', width: 90 }}&gt;集尘盒&lt;/Text&gt;&lt;Text style={{ fontSize: 15, color: '#CBD5E1' }}&gt;改造为集尘 / 样本双仓&lt;/Text&gt;&lt;/Box&gt;&#10;          &lt;Box style={{ flexDirection: 'row', gap: 12, alignItems: 'center' }}&gt;&lt;Text style={{ fontSize: 15, color: '#22D3EE', fontWeight: 'bold', width: 90 }}&gt;上盖&lt;/Text&gt;&lt;Text style={{ fontSize: 15, color: '#CBD5E1' }}&gt;保险杠 + 对接不锈钢机身&lt;/Text&gt;&lt;/Box&gt;&#10;        &lt;/Box&gt;&#10;      &lt;/Animation&gt;&#10;    &lt;/Box&gt;&#10;  &lt;/Box&gt;&#10;&lt;/Slide&gt;&#10;"/>
+        <p:cNvPr id="140" name="" descr="&lt;Slide type=&quot;content&quot;&gt;&#10;  &lt;Box style={{ width: '100%', height: '100%', background: '#0B1120', flexDirection: 'row' }}&gt;&#10;    &lt;Box style={{ width: '55%', height: '100%', justifyContent: 'center', alignItems: 'center', padding: '40px' }}&gt;&#10;      &lt;Image src=&quot;assets/robo_base.svg&quot; style={{ width: '100%', height: '100%', objectFit: 'contain' }} /&gt;&#10;    &lt;/Box&gt;&#10;    &lt;Box style={{ flex: 1, justifyContent: 'center', padding: '0 52px', gap: 14 }}&gt;&#10;      &lt;Animation animType=&quot;fadeIn&quot; duration={600}&gt;&#10;        &lt;Text style={{ fontSize: 32, color: '#E5EDF7', fontWeight: 'bold' }}&gt;扫地机器人底座结构&lt;/Text&gt;&#10;      &lt;/Animation&gt;&#10;      &lt;Animation animType=&quot;fadeIn&quot; startType=&quot;afterPrevious&quot; duration={600}&gt;&#10;        &lt;Text style={{ fontSize: 16, color: '#94A3B8', lineHeight: 1.8 }}&gt;爆炸视图自底向上六层，是整台 CMR 的「腿」与「神经」。改装只动上身，底盘全部保留。&lt;/Text&gt;&#10;      &lt;/Animation&gt;&#10;      &lt;Animation animType=&quot;fadeIn&quot; startType=&quot;afterPrevious&quot; duration={600}&gt;&#10;        &lt;Box style={{ gap: 10, marginTop: 4 }}&gt;&#10;          &lt;Box style={{ flexDirection: 'row', gap: 12, alignItems: 'center' }}&gt;&lt;Text style={{ fontSize: 15, color: '#22D3EE', fontWeight: 'bold', width: 90 }}&gt;底盘轮组&lt;/Text&gt;&lt;Text style={{ fontSize: 15, color: '#CBD5E1' }}&gt;差速 / 全向轮，适应地外起伏地形&lt;/Text&gt;&lt;/Box&gt;&#10;          &lt;Box style={{ flexDirection: 'row', gap: 12, alignItems: 'center' }}&gt;&lt;Text style={{ fontSize: 15, color: '#22D3EE', fontWeight: 'bold', width: 90 }}&gt;电源&lt;/Text&gt;&lt;Text style={{ fontSize: 15, color: '#CBD5E1' }}&gt;锂电池 + 太阳能板（西电 SiC MPPT）&lt;/Text&gt;&lt;/Box&gt;&#10;          &lt;Box style={{ flexDirection: 'row', gap: 12, alignItems: 'center' }}&gt;&lt;Text style={{ fontSize: 15, color: '#22D3EE', fontWeight: 'bold', width: 90 }}&gt;感知&lt;/Text&gt;&lt;Text style={{ fontSize: 15, color: '#CBD5E1' }}&gt;LiDAR + 视觉 SLAM 传感器&lt;/Text&gt;&lt;/Box&gt;&#10;          &lt;Box style={{ flexDirection: 'row', gap: 12, alignItems: 'center' }}&gt;&lt;Text style={{ fontSize: 15, color: '#22D3EE', fontWeight: 'bold', width: 90 }}&gt;控制&lt;/Text&gt;&lt;Text style={{ fontSize: 15, color: '#CBD5E1' }}&gt;ROS2 边缘主控制器&lt;/Text&gt;&lt;/Box&gt;&#10;          &lt;Box style={{ flexDirection: 'row', gap: 12, alignItems: 'center' }}&gt;&lt;Text style={{ fontSize: 15, color: '#22D3EE', fontWeight: 'bold', width: 90 }}&gt;集尘盒&lt;/Text&gt;&lt;Text style={{ fontSize: 15, color: '#CBD5E1' }}&gt;改造为集尘 / 样本双仓&lt;/Text&gt;&lt;/Box&gt;&#10;          &lt;Box style={{ flexDirection: 'row', gap: 12, alignItems: 'center' }}&gt;&lt;Text style={{ fontSize: 15, color: '#22D3EE', fontWeight: 'bold', width: 90 }}&gt;上盖&lt;/Text&gt;&lt;Text style={{ fontSize: 15, color: '#CBD5E1' }}&gt;保险杠 + 对接不锈钢机身&lt;/Text&gt;&lt;/Box&gt;&#10;        &lt;/Box&gt;&#10;      &lt;/Animation&gt;&#10;    &lt;/Box&gt;&#10;  &lt;/Box&gt;&#10;&lt;/Slide&gt;&#10;"/>
         <p:cNvGrpSpPr/>
         <p:nvPr/>
       </p:nvGrpSpPr>
@@ -11450,7 +11540,7 @@
       </p:grpSpPr>
       <p:sp>
         <p:nvSpPr>
-          <p:cNvPr id="140" name=""/>
+          <p:cNvPr id="141" name=""/>
           <p:cNvSpPr/>
           <p:nvPr/>
         </p:nvSpPr>
@@ -11474,7 +11564,7 @@
       </p:sp>
       <p:pic>
         <p:nvPicPr>
-          <p:cNvPr id="141" name=""/>
+          <p:cNvPr id="142" name=""/>
           <p:cNvPicPr>
             <a:picLocks noChangeAspect="1"/>
           </p:cNvPicPr>
@@ -11506,7 +11596,7 @@
       </p:pic>
       <p:sp>
         <p:nvSpPr>
-          <p:cNvPr id="142" name="" descr="{&quot;isTemplate&quot;:true,&quot;type&quot;:&quot;text&quot;}"/>
+          <p:cNvPr id="143" name="" descr="{&quot;isTemplate&quot;:true,&quot;type&quot;:&quot;text&quot;}"/>
           <p:cNvSpPr txBox="1"/>
           <p:nvPr/>
         </p:nvSpPr>
@@ -11541,7 +11631,7 @@
       </p:sp>
       <p:sp>
         <p:nvSpPr>
-          <p:cNvPr id="143" name="" descr="{&quot;isTemplate&quot;:true,&quot;type&quot;:&quot;text&quot;}"/>
+          <p:cNvPr id="144" name="" descr="{&quot;isTemplate&quot;:true,&quot;type&quot;:&quot;text&quot;}"/>
           <p:cNvSpPr txBox="1"/>
           <p:nvPr/>
         </p:nvSpPr>
@@ -11598,7 +11688,7 @@
       </p:sp>
       <p:sp>
         <p:nvSpPr>
-          <p:cNvPr id="144" name="" descr="{&quot;isTemplate&quot;:true,&quot;type&quot;:&quot;text&quot;}"/>
+          <p:cNvPr id="145" name="" descr="{&quot;isTemplate&quot;:true,&quot;type&quot;:&quot;text&quot;}"/>
           <p:cNvSpPr txBox="1"/>
           <p:nvPr/>
         </p:nvSpPr>
@@ -11633,7 +11723,7 @@
       </p:sp>
       <p:sp>
         <p:nvSpPr>
-          <p:cNvPr id="145" name="" descr="{&quot;isTemplate&quot;:true,&quot;type&quot;:&quot;text&quot;}"/>
+          <p:cNvPr id="146" name="" descr="{&quot;isTemplate&quot;:true,&quot;type&quot;:&quot;text&quot;}"/>
           <p:cNvSpPr txBox="1"/>
           <p:nvPr/>
         </p:nvSpPr>
@@ -11688,7 +11778,7 @@
       </p:sp>
       <p:sp>
         <p:nvSpPr>
-          <p:cNvPr id="146" name="" descr="{&quot;isTemplate&quot;:true,&quot;type&quot;:&quot;text&quot;}"/>
+          <p:cNvPr id="147" name="" descr="{&quot;isTemplate&quot;:true,&quot;type&quot;:&quot;text&quot;}"/>
           <p:cNvSpPr txBox="1"/>
           <p:nvPr/>
         </p:nvSpPr>
@@ -11723,7 +11813,7 @@
       </p:sp>
       <p:sp>
         <p:nvSpPr>
-          <p:cNvPr id="147" name="" descr="{&quot;isTemplate&quot;:true,&quot;type&quot;:&quot;text&quot;}"/>
+          <p:cNvPr id="148" name="" descr="{&quot;isTemplate&quot;:true,&quot;type&quot;:&quot;text&quot;}"/>
           <p:cNvSpPr txBox="1"/>
           <p:nvPr/>
         </p:nvSpPr>
@@ -11798,7 +11888,7 @@
       </p:sp>
       <p:sp>
         <p:nvSpPr>
-          <p:cNvPr id="148" name="" descr="{&quot;isTemplate&quot;:true,&quot;type&quot;:&quot;text&quot;}"/>
+          <p:cNvPr id="149" name="" descr="{&quot;isTemplate&quot;:true,&quot;type&quot;:&quot;text&quot;}"/>
           <p:cNvSpPr txBox="1"/>
           <p:nvPr/>
         </p:nvSpPr>
@@ -11833,7 +11923,7 @@
       </p:sp>
       <p:sp>
         <p:nvSpPr>
-          <p:cNvPr id="149" name="" descr="{&quot;isTemplate&quot;:true,&quot;type&quot;:&quot;text&quot;}"/>
+          <p:cNvPr id="150" name="" descr="{&quot;isTemplate&quot;:true,&quot;type&quot;:&quot;text&quot;}"/>
           <p:cNvSpPr txBox="1"/>
           <p:nvPr/>
         </p:nvSpPr>
@@ -11898,7 +11988,7 @@
       </p:sp>
       <p:sp>
         <p:nvSpPr>
-          <p:cNvPr id="150" name="" descr="{&quot;isTemplate&quot;:true,&quot;type&quot;:&quot;text&quot;}"/>
+          <p:cNvPr id="151" name="" descr="{&quot;isTemplate&quot;:true,&quot;type&quot;:&quot;text&quot;}"/>
           <p:cNvSpPr txBox="1"/>
           <p:nvPr/>
         </p:nvSpPr>
@@ -11933,7 +12023,7 @@
       </p:sp>
       <p:sp>
         <p:nvSpPr>
-          <p:cNvPr id="151" name="" descr="{&quot;isTemplate&quot;:true,&quot;type&quot;:&quot;text&quot;}"/>
+          <p:cNvPr id="152" name="" descr="{&quot;isTemplate&quot;:true,&quot;type&quot;:&quot;text&quot;}"/>
           <p:cNvSpPr txBox="1"/>
           <p:nvPr/>
         </p:nvSpPr>
@@ -11978,7 +12068,7 @@
       </p:sp>
       <p:sp>
         <p:nvSpPr>
-          <p:cNvPr id="152" name="" descr="{&quot;isTemplate&quot;:true,&quot;type&quot;:&quot;text&quot;}"/>
+          <p:cNvPr id="153" name="" descr="{&quot;isTemplate&quot;:true,&quot;type&quot;:&quot;text&quot;}"/>
           <p:cNvSpPr txBox="1"/>
           <p:nvPr/>
         </p:nvSpPr>
@@ -12013,7 +12103,7 @@
       </p:sp>
       <p:sp>
         <p:nvSpPr>
-          <p:cNvPr id="153" name="" descr="{&quot;isTemplate&quot;:true,&quot;type&quot;:&quot;text&quot;}"/>
+          <p:cNvPr id="154" name="" descr="{&quot;isTemplate&quot;:true,&quot;type&quot;:&quot;text&quot;}"/>
           <p:cNvSpPr txBox="1"/>
           <p:nvPr/>
         </p:nvSpPr>
@@ -12068,7 +12158,7 @@
       </p:sp>
       <p:sp>
         <p:nvSpPr>
-          <p:cNvPr id="154" name="" descr="{&quot;isTemplate&quot;:true,&quot;type&quot;:&quot;text&quot;}"/>
+          <p:cNvPr id="155" name="" descr="{&quot;isTemplate&quot;:true,&quot;type&quot;:&quot;text&quot;}"/>
           <p:cNvSpPr txBox="1"/>
           <p:nvPr/>
         </p:nvSpPr>
@@ -12103,7 +12193,7 @@
       </p:sp>
       <p:sp>
         <p:nvSpPr>
-          <p:cNvPr id="155" name="" descr="{&quot;isTemplate&quot;:true,&quot;type&quot;:&quot;text&quot;}"/>
+          <p:cNvPr id="156" name="" descr="{&quot;isTemplate&quot;:true,&quot;type&quot;:&quot;text&quot;}"/>
           <p:cNvSpPr txBox="1"/>
           <p:nvPr/>
         </p:nvSpPr>
@@ -12179,20 +12269,20 @@
                             </p:stCondLst>
                             <p:childTnLst>
                               <p:par>
-                                <p:cTn id="286" presetID="10" presetClass="entr" presetSubtype="0" fill="hold" grpId="0" nodeType="withEffect">
+                                <p:cTn id="289" presetID="10" presetClass="entr" presetSubtype="0" fill="hold" grpId="0" nodeType="withEffect">
                                   <p:stCondLst>
                                     <p:cond delay="0"/>
                                   </p:stCondLst>
                                   <p:childTnLst>
                                     <p:set>
                                       <p:cBhvr>
-                                        <p:cTn id="287" dur="1" fill="hold">
+                                        <p:cTn id="290" dur="1" fill="hold">
                                           <p:stCondLst>
                                             <p:cond delay="0"/>
                                           </p:stCondLst>
                                         </p:cTn>
                                         <p:tgtEl>
-                                          <p:spTgt spid="142"/>
+                                          <p:spTgt spid="143"/>
                                         </p:tgtEl>
                                         <p:attrNameLst>
                                           <p:attrName>style.visibility</p:attrName>
@@ -12204,44 +12294,9 @@
                                     </p:set>
                                     <p:animEffect transition="in" filter="fade">
                                       <p:cBhvr>
-                                        <p:cTn id="288" dur="600"/>
-                                        <p:tgtEl>
-                                          <p:spTgt spid="142"/>
-                                        </p:tgtEl>
-                                      </p:cBhvr>
-                                    </p:animEffect>
-                                  </p:childTnLst>
-                                </p:cTn>
-                              </p:par>
-                              <p:par>
-                                <p:cTn id="289" presetID="10" presetClass="entr" presetSubtype="0" fill="hold" grpId="2" nodeType="withEffect">
-                                  <p:stCondLst>
-                                    <p:cond delay="0"/>
-                                  </p:stCondLst>
-                                  <p:childTnLst>
-                                    <p:set>
-                                      <p:cBhvr>
-                                        <p:cTn id="290" dur="1" fill="hold">
-                                          <p:stCondLst>
-                                            <p:cond delay="0"/>
-                                          </p:stCondLst>
-                                        </p:cTn>
-                                        <p:tgtEl>
-                                          <p:spTgt spid="145"/>
-                                        </p:tgtEl>
-                                        <p:attrNameLst>
-                                          <p:attrName>style.visibility</p:attrName>
-                                        </p:attrNameLst>
-                                      </p:cBhvr>
-                                      <p:to>
-                                        <p:strVal val="visible"/>
-                                      </p:to>
-                                    </p:set>
-                                    <p:animEffect transition="in" filter="fade">
-                                      <p:cBhvr>
                                         <p:cTn id="291" dur="600"/>
                                         <p:tgtEl>
-                                          <p:spTgt spid="145"/>
+                                          <p:spTgt spid="143"/>
                                         </p:tgtEl>
                                       </p:cBhvr>
                                     </p:animEffect>
@@ -12592,6 +12647,41 @@
                                         <p:cTn id="321" dur="600"/>
                                         <p:tgtEl>
                                           <p:spTgt spid="155"/>
+                                        </p:tgtEl>
+                                      </p:cBhvr>
+                                    </p:animEffect>
+                                  </p:childTnLst>
+                                </p:cTn>
+                              </p:par>
+                              <p:par>
+                                <p:cTn id="322" presetID="10" presetClass="entr" presetSubtype="0" fill="hold" grpId="2" nodeType="withEffect">
+                                  <p:stCondLst>
+                                    <p:cond delay="0"/>
+                                  </p:stCondLst>
+                                  <p:childTnLst>
+                                    <p:set>
+                                      <p:cBhvr>
+                                        <p:cTn id="323" dur="1" fill="hold">
+                                          <p:stCondLst>
+                                            <p:cond delay="0"/>
+                                          </p:stCondLst>
+                                        </p:cTn>
+                                        <p:tgtEl>
+                                          <p:spTgt spid="156"/>
+                                        </p:tgtEl>
+                                        <p:attrNameLst>
+                                          <p:attrName>style.visibility</p:attrName>
+                                        </p:attrNameLst>
+                                      </p:cBhvr>
+                                      <p:to>
+                                        <p:strVal val="visible"/>
+                                      </p:to>
+                                    </p:set>
+                                    <p:animEffect transition="in" filter="fade">
+                                      <p:cBhvr>
+                                        <p:cTn id="324" dur="600"/>
+                                        <p:tgtEl>
+                                          <p:spTgt spid="156"/>
                                         </p:tgtEl>
                                       </p:cBhvr>
                                     </p:animEffect>
@@ -12608,20 +12698,20 @@
                             </p:stCondLst>
                             <p:childTnLst>
                               <p:par>
-                                <p:cTn id="322" presetID="10" presetClass="entr" presetSubtype="0" fill="hold" grpId="1" nodeType="afterEffect">
+                                <p:cTn id="325" presetID="10" presetClass="entr" presetSubtype="0" fill="hold" grpId="1" nodeType="afterEffect">
                                   <p:stCondLst>
                                     <p:cond delay="0"/>
                                   </p:stCondLst>
                                   <p:childTnLst>
                                     <p:set>
                                       <p:cBhvr>
-                                        <p:cTn id="323" dur="1" fill="hold">
+                                        <p:cTn id="326" dur="1" fill="hold">
                                           <p:stCondLst>
                                             <p:cond delay="0"/>
                                           </p:stCondLst>
                                         </p:cTn>
                                         <p:tgtEl>
-                                          <p:spTgt spid="143"/>
+                                          <p:spTgt spid="144"/>
                                         </p:tgtEl>
                                         <p:attrNameLst>
                                           <p:attrName>style.visibility</p:attrName>
@@ -12633,9 +12723,9 @@
                                     </p:set>
                                     <p:animEffect transition="in" filter="fade">
                                       <p:cBhvr>
-                                        <p:cTn id="324" dur="600"/>
-                                        <p:tgtEl>
-                                          <p:spTgt spid="143"/>
+                                        <p:cTn id="327" dur="600"/>
+                                        <p:tgtEl>
+                                          <p:spTgt spid="144"/>
                                         </p:tgtEl>
                                       </p:cBhvr>
                                     </p:animEffect>
@@ -12652,20 +12742,20 @@
                             </p:stCondLst>
                             <p:childTnLst>
                               <p:par>
-                                <p:cTn id="325" presetID="10" presetClass="entr" presetSubtype="0" fill="hold" grpId="2" nodeType="afterEffect">
+                                <p:cTn id="328" presetID="10" presetClass="entr" presetSubtype="0" fill="hold" grpId="2" nodeType="afterEffect">
                                   <p:stCondLst>
                                     <p:cond delay="0"/>
                                   </p:stCondLst>
                                   <p:childTnLst>
                                     <p:set>
                                       <p:cBhvr>
-                                        <p:cTn id="326" dur="1" fill="hold">
+                                        <p:cTn id="329" dur="1" fill="hold">
                                           <p:stCondLst>
                                             <p:cond delay="0"/>
                                           </p:stCondLst>
                                         </p:cTn>
                                         <p:tgtEl>
-                                          <p:spTgt spid="144"/>
+                                          <p:spTgt spid="145"/>
                                         </p:tgtEl>
                                         <p:attrNameLst>
                                           <p:attrName>style.visibility</p:attrName>
@@ -12677,9 +12767,9 @@
                                     </p:set>
                                     <p:animEffect transition="in" filter="fade">
                                       <p:cBhvr>
-                                        <p:cTn id="327" dur="600"/>
-                                        <p:tgtEl>
-                                          <p:spTgt spid="144"/>
+                                        <p:cTn id="330" dur="600"/>
+                                        <p:tgtEl>
+                                          <p:spTgt spid="145"/>
                                         </p:tgtEl>
                                       </p:cBhvr>
                                     </p:animEffect>
@@ -12718,7 +12808,7 @@
   <p:cSld>
     <p:spTree>
       <p:nvGrpSpPr>
-        <p:cNvPr id="156" name="" descr="&lt;Slide type=&quot;content&quot;&gt;&#10;  &lt;Box style={{ width: '100%', height: '100%', background: '#0B1120', flexDirection: 'column' }}&gt;&#10;    &lt;Box style={{ height: '56%', justifyContent: 'center', alignItems: 'center', padding: '24px 40px 0' }}&gt;&#10;      &lt;Image src=&quot;assets/cmr_structure.svg&quot; style={{ width: '100%', height: '100%', objectFit: 'contain' }} /&gt;&#10;    &lt;/Box&gt;&#10;    &lt;Box style={{ flex: 1, justifyContent: 'center', padding: '0 48px 36px', gap: 14 }}&gt;&#10;      &lt;Animation animType=&quot;fadeIn&quot; duration={600}&gt;&#10;        &lt;Text style={{ fontSize: 30, color: '#E5EDF7', fontWeight: 'bold', textAlign: 'center' }}&gt;整体改装结构：四层叠加&lt;/Text&gt;&#10;      &lt;/Animation&gt;&#10;      &lt;Animation animType=&quot;fadeIn&quot; startType=&quot;afterPrevious&quot; duration={600}&gt;&#10;        &lt;Box style={{ flexDirection: 'row', gap: 14 }}&gt;&#10;          &lt;Box style={{ flex: 1, background: '#0F1B33', border: '1px solid #1E3A5F', borderRadius: 12, padding: 16 }}&gt;&lt;Text style={{ fontSize: 17, color: '#3B82F6', fontWeight: 'bold' }}&gt;不锈钢外壳层&lt;/Text&gt;&lt;Text style={{ fontSize: 13, color: '#94A3B8', marginTop: 6, lineHeight: 1.6 }}&gt;316L 机身，抗辐照与散热骨架&lt;/Text&gt;&lt;/Box&gt;&#10;          &lt;Box style={{ flex: 1, background: '#0F1B33', border: '1px solid #1E3A5F', borderRadius: 12, padding: 16 }}&gt;&lt;Text style={{ fontSize: 17, color: '#22D3EE', fontWeight: 'bold' }}&gt;抗辐射算力层&lt;/Text&gt;&lt;Text style={{ fontSize: 13, color: '#94A3B8', marginTop: 6, lineHeight: 1.6 }}&gt;西电 / 广州三代半电源-算力主板&lt;/Text&gt;&lt;/Box&gt;&#10;          &lt;Box style={{ flex: 1, background: '#0F1B33', border: '1px solid #1E3A5F', borderRadius: 12, padding: 16 }}&gt;&lt;Text style={{ fontSize: 17, color: '#F59E0B', fontWeight: 'bold' }}&gt;工具头层&lt;/Text&gt;&lt;Text style={{ fontSize: 13, color: '#94A3B8', marginTop: 6, lineHeight: 1.6 }}&gt;多光谱相机 + 钻采机构&lt;/Text&gt;&lt;/Box&gt;&#10;          &lt;Box style={{ flex: 1, background: '#0F1B33', border: '1px solid #1E3A5F', borderRadius: 12, padding: 16 }}&gt;&lt;Text style={{ fontSize: 17, color: '#34D399', fontWeight: 'bold' }}&gt;通信层&lt;/Text&gt;&lt;Text style={{ fontSize: 13, color: '#94A3B8', marginTop: 6, lineHeight: 1.6 }}&gt;星链天线 + 区块链账本&lt;/Text&gt;&lt;/Box&gt;&#10;        &lt;/Box&gt;&#10;      &lt;/Animation&gt;&#10;    &lt;/Box&gt;&#10;  &lt;/Box&gt;&#10;&lt;/Slide&gt;&#10;"/>
+        <p:cNvPr id="157" name="" descr="&lt;Slide type=&quot;content&quot;&gt;&#10;  &lt;Box style={{ width: '100%', height: '100%', background: '#0B1120', flexDirection: 'column' }}&gt;&#10;    &lt;Box style={{ height: '56%', justifyContent: 'center', alignItems: 'center', padding: '24px 40px 0' }}&gt;&#10;      &lt;Image src=&quot;assets/cmr_structure.svg&quot; style={{ width: '100%', height: '100%', objectFit: 'contain' }} /&gt;&#10;    &lt;/Box&gt;&#10;    &lt;Box style={{ flex: 1, justifyContent: 'center', padding: '0 48px 36px', gap: 14 }}&gt;&#10;      &lt;Animation animType=&quot;fadeIn&quot; duration={600}&gt;&#10;        &lt;Text style={{ fontSize: 30, color: '#E5EDF7', fontWeight: 'bold', textAlign: 'center' }}&gt;整体改装结构：四层叠加&lt;/Text&gt;&#10;      &lt;/Animation&gt;&#10;      &lt;Animation animType=&quot;fadeIn&quot; startType=&quot;afterPrevious&quot; duration={600}&gt;&#10;        &lt;Box style={{ flexDirection: 'row', gap: 14 }}&gt;&#10;          &lt;Box style={{ flex: 1, background: '#0F1B33', border: '1px solid #1E3A5F', borderRadius: 12, padding: 16 }}&gt;&lt;Text style={{ fontSize: 17, color: '#3B82F6', fontWeight: 'bold' }}&gt;不锈钢外壳层&lt;/Text&gt;&lt;Text style={{ fontSize: 13, color: '#94A3B8', marginTop: 6, lineHeight: 1.6 }}&gt;316L 机身，抗辐照与散热骨架&lt;/Text&gt;&lt;/Box&gt;&#10;          &lt;Box style={{ flex: 1, background: '#0F1B33', border: '1px solid #1E3A5F', borderRadius: 12, padding: 16 }}&gt;&lt;Text style={{ fontSize: 17, color: '#22D3EE', fontWeight: 'bold' }}&gt;抗辐射算力层&lt;/Text&gt;&lt;Text style={{ fontSize: 13, color: '#94A3B8', marginTop: 6, lineHeight: 1.6 }}&gt;西电 / 广州三代半电源-算力主板&lt;/Text&gt;&lt;/Box&gt;&#10;          &lt;Box style={{ flex: 1, background: '#0F1B33', border: '1px solid #1E3A5F', borderRadius: 12, padding: 16 }}&gt;&lt;Text style={{ fontSize: 17, color: '#F59E0B', fontWeight: 'bold' }}&gt;工具头层&lt;/Text&gt;&lt;Text style={{ fontSize: 13, color: '#94A3B8', marginTop: 6, lineHeight: 1.6 }}&gt;多光谱相机 + 钻采机构&lt;/Text&gt;&lt;/Box&gt;&#10;          &lt;Box style={{ flex: 1, background: '#0F1B33', border: '1px solid #1E3A5F', borderRadius: 12, padding: 16 }}&gt;&lt;Text style={{ fontSize: 17, color: '#34D399', fontWeight: 'bold' }}&gt;通信层&lt;/Text&gt;&lt;Text style={{ fontSize: 13, color: '#94A3B8', marginTop: 6, lineHeight: 1.6 }}&gt;星链天线 + 区块链账本&lt;/Text&gt;&lt;/Box&gt;&#10;        &lt;/Box&gt;&#10;      &lt;/Animation&gt;&#10;    &lt;/Box&gt;&#10;  &lt;/Box&gt;&#10;&lt;/Slide&gt;&#10;"/>
         <p:cNvGrpSpPr/>
         <p:nvPr/>
       </p:nvGrpSpPr>
@@ -12732,7 +12822,7 @@
       </p:grpSpPr>
       <p:sp>
         <p:nvSpPr>
-          <p:cNvPr id="157" name=""/>
+          <p:cNvPr id="158" name=""/>
           <p:cNvSpPr/>
           <p:nvPr/>
         </p:nvSpPr>
@@ -12756,7 +12846,7 @@
       </p:sp>
       <p:pic>
         <p:nvPicPr>
-          <p:cNvPr id="158" name=""/>
+          <p:cNvPr id="159" name=""/>
           <p:cNvPicPr>
             <a:picLocks noChangeAspect="1"/>
           </p:cNvPicPr>
@@ -12788,7 +12878,7 @@
       </p:pic>
       <p:sp>
         <p:nvSpPr>
-          <p:cNvPr id="159" name="" descr="{&quot;isTemplate&quot;:true,&quot;type&quot;:&quot;text&quot;}"/>
+          <p:cNvPr id="160" name="" descr="{&quot;isTemplate&quot;:true,&quot;type&quot;:&quot;text&quot;}"/>
           <p:cNvSpPr txBox="1"/>
           <p:nvPr/>
         </p:nvSpPr>
@@ -12823,7 +12913,7 @@
       </p:sp>
       <p:sp>
         <p:nvSpPr>
-          <p:cNvPr id="160" name=""/>
+          <p:cNvPr id="161" name=""/>
           <p:cNvSpPr/>
           <p:nvPr/>
         </p:nvSpPr>
@@ -12854,7 +12944,7 @@
       </p:sp>
       <p:sp>
         <p:nvSpPr>
-          <p:cNvPr id="161" name="" descr="{&quot;isTemplate&quot;:true,&quot;type&quot;:&quot;text&quot;}"/>
+          <p:cNvPr id="162" name="" descr="{&quot;isTemplate&quot;:true,&quot;type&quot;:&quot;text&quot;}"/>
           <p:cNvSpPr txBox="1"/>
           <p:nvPr/>
         </p:nvSpPr>
@@ -12889,7 +12979,7 @@
       </p:sp>
       <p:sp>
         <p:nvSpPr>
-          <p:cNvPr id="162" name="" descr="{&quot;isTemplate&quot;:true,&quot;type&quot;:&quot;text&quot;}"/>
+          <p:cNvPr id="163" name="" descr="{&quot;isTemplate&quot;:true,&quot;type&quot;:&quot;text&quot;}"/>
           <p:cNvSpPr txBox="1"/>
           <p:nvPr/>
         </p:nvSpPr>
@@ -12934,7 +13024,7 @@
       </p:sp>
       <p:sp>
         <p:nvSpPr>
-          <p:cNvPr id="163" name=""/>
+          <p:cNvPr id="164" name=""/>
           <p:cNvSpPr/>
           <p:nvPr/>
         </p:nvSpPr>
@@ -12965,7 +13055,7 @@
       </p:sp>
       <p:sp>
         <p:nvSpPr>
-          <p:cNvPr id="164" name="" descr="{&quot;isTemplate&quot;:true,&quot;type&quot;:&quot;text&quot;}"/>
+          <p:cNvPr id="165" name="" descr="{&quot;isTemplate&quot;:true,&quot;type&quot;:&quot;text&quot;}"/>
           <p:cNvSpPr txBox="1"/>
           <p:nvPr/>
         </p:nvSpPr>
@@ -13000,7 +13090,7 @@
       </p:sp>
       <p:sp>
         <p:nvSpPr>
-          <p:cNvPr id="165" name="" descr="{&quot;isTemplate&quot;:true,&quot;type&quot;:&quot;text&quot;}"/>
+          <p:cNvPr id="166" name="" descr="{&quot;isTemplate&quot;:true,&quot;type&quot;:&quot;text&quot;}"/>
           <p:cNvSpPr txBox="1"/>
           <p:nvPr/>
         </p:nvSpPr>
@@ -13075,7 +13165,7 @@
       </p:sp>
       <p:sp>
         <p:nvSpPr>
-          <p:cNvPr id="166" name=""/>
+          <p:cNvPr id="167" name=""/>
           <p:cNvSpPr/>
           <p:nvPr/>
         </p:nvSpPr>
@@ -13106,7 +13196,7 @@
       </p:sp>
       <p:sp>
         <p:nvSpPr>
-          <p:cNvPr id="167" name="" descr="{&quot;isTemplate&quot;:true,&quot;type&quot;:&quot;text&quot;}"/>
+          <p:cNvPr id="168" name="" descr="{&quot;isTemplate&quot;:true,&quot;type&quot;:&quot;text&quot;}"/>
           <p:cNvSpPr txBox="1"/>
           <p:nvPr/>
         </p:nvSpPr>
@@ -13141,7 +13231,7 @@
       </p:sp>
       <p:sp>
         <p:nvSpPr>
-          <p:cNvPr id="168" name="" descr="{&quot;isTemplate&quot;:true,&quot;type&quot;:&quot;text&quot;}"/>
+          <p:cNvPr id="169" name="" descr="{&quot;isTemplate&quot;:true,&quot;type&quot;:&quot;text&quot;}"/>
           <p:cNvSpPr txBox="1"/>
           <p:nvPr/>
         </p:nvSpPr>
@@ -13196,7 +13286,7 @@
       </p:sp>
       <p:sp>
         <p:nvSpPr>
-          <p:cNvPr id="169" name=""/>
+          <p:cNvPr id="170" name=""/>
           <p:cNvSpPr/>
           <p:nvPr/>
         </p:nvSpPr>
@@ -13227,7 +13317,7 @@
       </p:sp>
       <p:sp>
         <p:nvSpPr>
-          <p:cNvPr id="170" name="" descr="{&quot;isTemplate&quot;:true,&quot;type&quot;:&quot;text&quot;}"/>
+          <p:cNvPr id="171" name="" descr="{&quot;isTemplate&quot;:true,&quot;type&quot;:&quot;text&quot;}"/>
           <p:cNvSpPr txBox="1"/>
           <p:nvPr/>
         </p:nvSpPr>
@@ -13262,7 +13352,7 @@
       </p:sp>
       <p:sp>
         <p:nvSpPr>
-          <p:cNvPr id="171" name="" descr="{&quot;isTemplate&quot;:true,&quot;type&quot;:&quot;text&quot;}"/>
+          <p:cNvPr id="172" name="" descr="{&quot;isTemplate&quot;:true,&quot;type&quot;:&quot;text&quot;}"/>
           <p:cNvSpPr txBox="1"/>
           <p:nvPr/>
         </p:nvSpPr>
@@ -13338,20 +13428,20 @@
                             </p:stCondLst>
                             <p:childTnLst>
                               <p:par>
-                                <p:cTn id="328" presetID="10" presetClass="entr" presetSubtype="0" fill="hold" grpId="0" nodeType="withEffect">
+                                <p:cTn id="331" presetID="10" presetClass="entr" presetSubtype="0" fill="hold" grpId="0" nodeType="withEffect">
                                   <p:stCondLst>
                                     <p:cond delay="0"/>
                                   </p:stCondLst>
                                   <p:childTnLst>
                                     <p:set>
                                       <p:cBhvr>
-                                        <p:cTn id="329" dur="1" fill="hold">
+                                        <p:cTn id="332" dur="1" fill="hold">
                                           <p:stCondLst>
                                             <p:cond delay="0"/>
                                           </p:stCondLst>
                                         </p:cTn>
                                         <p:tgtEl>
-                                          <p:spTgt spid="159"/>
+                                          <p:spTgt spid="160"/>
                                         </p:tgtEl>
                                         <p:attrNameLst>
                                           <p:attrName>style.visibility</p:attrName>
@@ -13363,44 +13453,9 @@
                                     </p:set>
                                     <p:animEffect transition="in" filter="fade">
                                       <p:cBhvr>
-                                        <p:cTn id="330" dur="600"/>
-                                        <p:tgtEl>
-                                          <p:spTgt spid="159"/>
-                                        </p:tgtEl>
-                                      </p:cBhvr>
-                                    </p:animEffect>
-                                  </p:childTnLst>
-                                </p:cTn>
-                              </p:par>
-                              <p:par>
-                                <p:cTn id="331" presetID="10" presetClass="entr" presetSubtype="0" fill="hold" grpId="1" nodeType="withEffect">
-                                  <p:stCondLst>
-                                    <p:cond delay="0"/>
-                                  </p:stCondLst>
-                                  <p:childTnLst>
-                                    <p:set>
-                                      <p:cBhvr>
-                                        <p:cTn id="332" dur="1" fill="hold">
-                                          <p:stCondLst>
-                                            <p:cond delay="0"/>
-                                          </p:stCondLst>
-                                        </p:cTn>
-                                        <p:tgtEl>
-                                          <p:spTgt spid="161"/>
-                                        </p:tgtEl>
-                                        <p:attrNameLst>
-                                          <p:attrName>style.visibility</p:attrName>
-                                        </p:attrNameLst>
-                                      </p:cBhvr>
-                                      <p:to>
-                                        <p:strVal val="visible"/>
-                                      </p:to>
-                                    </p:set>
-                                    <p:animEffect transition="in" filter="fade">
-                                      <p:cBhvr>
                                         <p:cTn id="333" dur="600"/>
                                         <p:tgtEl>
-                                          <p:spTgt spid="161"/>
+                                          <p:spTgt spid="160"/>
                                         </p:tgtEl>
                                       </p:cBhvr>
                                     </p:animEffect>
@@ -13751,6 +13806,41 @@
                                         <p:cTn id="363" dur="600"/>
                                         <p:tgtEl>
                                           <p:spTgt spid="171"/>
+                                        </p:tgtEl>
+                                      </p:cBhvr>
+                                    </p:animEffect>
+                                  </p:childTnLst>
+                                </p:cTn>
+                              </p:par>
+                              <p:par>
+                                <p:cTn id="364" presetID="10" presetClass="entr" presetSubtype="0" fill="hold" grpId="1" nodeType="withEffect">
+                                  <p:stCondLst>
+                                    <p:cond delay="0"/>
+                                  </p:stCondLst>
+                                  <p:childTnLst>
+                                    <p:set>
+                                      <p:cBhvr>
+                                        <p:cTn id="365" dur="1" fill="hold">
+                                          <p:stCondLst>
+                                            <p:cond delay="0"/>
+                                          </p:stCondLst>
+                                        </p:cTn>
+                                        <p:tgtEl>
+                                          <p:spTgt spid="172"/>
+                                        </p:tgtEl>
+                                        <p:attrNameLst>
+                                          <p:attrName>style.visibility</p:attrName>
+                                        </p:attrNameLst>
+                                      </p:cBhvr>
+                                      <p:to>
+                                        <p:strVal val="visible"/>
+                                      </p:to>
+                                    </p:set>
+                                    <p:animEffect transition="in" filter="fade">
+                                      <p:cBhvr>
+                                        <p:cTn id="366" dur="600"/>
+                                        <p:tgtEl>
+                                          <p:spTgt spid="172"/>
                                         </p:tgtEl>
                                       </p:cBhvr>
                                     </p:animEffect>
@@ -13767,20 +13857,20 @@
                             </p:stCondLst>
                             <p:childTnLst>
                               <p:par>
-                                <p:cTn id="364" presetID="10" presetClass="entr" presetSubtype="0" fill="hold" grpId="1" nodeType="afterEffect">
+                                <p:cTn id="367" presetID="10" presetClass="entr" presetSubtype="0" fill="hold" grpId="1" nodeType="afterEffect">
                                   <p:stCondLst>
                                     <p:cond delay="0"/>
                                   </p:stCondLst>
                                   <p:childTnLst>
                                     <p:set>
                                       <p:cBhvr>
-                                        <p:cTn id="365" dur="1" fill="hold">
+                                        <p:cTn id="368" dur="1" fill="hold">
                                           <p:stCondLst>
                                             <p:cond delay="0"/>
                                           </p:stCondLst>
                                         </p:cTn>
                                         <p:tgtEl>
-                                          <p:spTgt spid="160"/>
+                                          <p:spTgt spid="161"/>
                                         </p:tgtEl>
                                         <p:attrNameLst>
                                           <p:attrName>style.visibility</p:attrName>
@@ -13792,9 +13882,9 @@
                                     </p:set>
                                     <p:animEffect transition="in" filter="fade">
                                       <p:cBhvr>
-                                        <p:cTn id="366" dur="600"/>
-                                        <p:tgtEl>
-                                          <p:spTgt spid="160"/>
+                                        <p:cTn id="369" dur="600"/>
+                                        <p:tgtEl>
+                                          <p:spTgt spid="161"/>
                                         </p:tgtEl>
                                       </p:cBhvr>
                                     </p:animEffect>
@@ -13833,7 +13923,7 @@
   <p:cSld>
     <p:spTree>
       <p:nvGrpSpPr>
-        <p:cNvPr id="172" name="" descr="&lt;Slide type=&quot;content&quot;&gt;&#10;  &lt;Box style={{ width: '100%', height: '100%', background: '#0B1120', flexDirection: 'row' }}&gt;&#10;    &lt;Box style={{ width: '34%', height: '100%', justifyContent: 'center', padding: '0 48px', background: '#0F1B33' }}&gt;&#10;      &lt;Text style={{ fontSize: 40, color: '#E5EDF7', fontWeight: 'bold', lineHeight: 1.15 }}&gt;西电第三代&lt;Text style={{ color: '#22D3EE' }}&gt;&lt;br/&gt;半导体芯片&lt;/Text&gt;&lt;/Text&gt;&#10;      &lt;Text style={{ fontSize: 15, color: '#94A3B8', marginTop: 22, lineHeight: 1.7 }}&gt;抗辐射 · 耐高温&lt;Text style={{ color: '#94A3B8' }}&gt;&lt;br/&gt;&lt;/Text&gt;耐高压 · 大功率&lt;/Text&gt;&#10;    &lt;/Box&gt;&#10;    &lt;Box style={{ flex: 1, justifyContent: 'center', padding: '0 56px', gap: 14 }}&gt;&#10;      &lt;Animation animType=&quot;fadeIn&quot; duration={600}&gt;&#10;        &lt;Text style={{ fontSize: 16, color: '#CBD5E1', lineHeight: 1.8 }}&gt;· &lt;Text style={{ color: '#3B82F6', fontWeight: 'bold' }}&gt;西安电子科技大学&lt;/Text&gt;：抗辐射 SiC 功率器件随天舟六号入轨验证，面向航天 / 星链。&lt;/Text&gt;&#10;      &lt;/Animation&gt;&#10;      &lt;Animation animType=&quot;fadeIn&quot; startType=&quot;afterPrevious&quot; duration={600}&gt;&#10;        &lt;Text style={{ fontSize: 16, color: '#CBD5E1', lineHeight: 1.8 }}&gt;· &lt;Text style={{ color: '#22D3EE', fontWeight: 'bold' }}&gt;广州黄埔创新中心&lt;/Text&gt;（郝跃院士领衔）：6–8 英寸 GaN 中试线，抗辐射 / 耐高温特性。&lt;/Text&gt;&#10;      &lt;/Animation&gt;&#10;      &lt;Animation animType=&quot;fadeIn&quot; startType=&quot;afterPrevious&quot; duration={600}&gt;&#10;        &lt;Text style={{ fontSize: 16, color: '#CBD5E1', lineHeight: 1.8 }}&gt;· &lt;Text style={{ color: '#F59E0B', fontWeight: 'bold' }}&gt;南沙万顷沙&lt;/Text&gt;：芯粤能（车规 SiC 主驱）、南砂晶圆（12&quot; SiC 衬底）、芯聚能（功率模块）。&lt;/Text&gt;&#10;      &lt;/Animation&gt;&#10;      &lt;Animation animType=&quot;fadeIn&quot; startType=&quot;afterPrevious&quot; duration={600}&gt;&#10;        &lt;Text style={{ fontSize: 16, color: '#CBD5E1', lineHeight: 1.8 }}&gt;· &lt;Text style={{ color: '#34D399', fontWeight: 'bold' }}&gt;落地&lt;/Text&gt;：SiC 功率器件 + 宇航级 SoC 合成「电源-算力合一」主板。&lt;/Text&gt;&#10;      &lt;/Animation&gt;&#10;      &lt;Animation animType=&quot;fadeIn&quot; startType=&quot;afterPrevious&quot; duration={600}&gt;&#10;        &lt;Text style={{ fontSize: 15, color: '#64748B', lineHeight: 1.7 }}&gt;⚠ 仍需：辐照试验 + 飞行认证方可上星。&lt;/Text&gt;&#10;      &lt;/Animation&gt;&#10;    &lt;/Box&gt;&#10;  &lt;/Box&gt;&#10;&lt;/Slide&gt;&#10;"/>
+        <p:cNvPr id="173" name="" descr="&lt;Slide type=&quot;content&quot;&gt;&#10;  &lt;Box style={{ width: '100%', height: '100%', background: '#0B1120', flexDirection: 'row' }}&gt;&#10;    &lt;Box style={{ width: '34%', height: '100%', justifyContent: 'center', padding: '0 48px', background: '#0F1B33' }}&gt;&#10;      &lt;Text style={{ fontSize: 40, color: '#E5EDF7', fontWeight: 'bold', lineHeight: 1.15 }}&gt;西电第三代&lt;Text style={{ color: '#22D3EE' }}&gt;&lt;br/&gt;半导体芯片&lt;/Text&gt;&lt;/Text&gt;&#10;      &lt;Text style={{ fontSize: 15, color: '#94A3B8', marginTop: 22, lineHeight: 1.7 }}&gt;抗辐射 · 耐高温&lt;Text style={{ color: '#94A3B8' }}&gt;&lt;br/&gt;&lt;/Text&gt;耐高压 · 大功率&lt;/Text&gt;&#10;    &lt;/Box&gt;&#10;    &lt;Box style={{ flex: 1, justifyContent: 'center', padding: '0 56px', gap: 14 }}&gt;&#10;      &lt;Animation animType=&quot;fadeIn&quot; duration={600}&gt;&#10;        &lt;Text style={{ fontSize: 16, color: '#CBD5E1', lineHeight: 1.8 }}&gt;· &lt;Text style={{ color: '#3B82F6', fontWeight: 'bold' }}&gt;西安电子科技大学&lt;/Text&gt;：抗辐射 SiC 功率器件随天舟六号入轨验证，面向航天 / 星链。&lt;/Text&gt;&#10;      &lt;/Animation&gt;&#10;      &lt;Animation animType=&quot;fadeIn&quot; startType=&quot;afterPrevious&quot; duration={600}&gt;&#10;        &lt;Text style={{ fontSize: 16, color: '#CBD5E1', lineHeight: 1.8 }}&gt;· &lt;Text style={{ color: '#22D3EE', fontWeight: 'bold' }}&gt;广州黄埔创新中心&lt;/Text&gt;（郝跃院士领衔）：6–8 英寸 GaN 中试线，抗辐射 / 耐高温特性。&lt;/Text&gt;&#10;      &lt;/Animation&gt;&#10;      &lt;Animation animType=&quot;fadeIn&quot; startType=&quot;afterPrevious&quot; duration={600}&gt;&#10;        &lt;Text style={{ fontSize: 16, color: '#CBD5E1', lineHeight: 1.8 }}&gt;· &lt;Text style={{ color: '#F59E0B', fontWeight: 'bold' }}&gt;南沙万顷沙&lt;/Text&gt;：芯粤能（车规 SiC 主驱）、南砂晶圆（12&quot; SiC 衬底）、芯聚能（功率模块）。&lt;/Text&gt;&#10;      &lt;/Animation&gt;&#10;      &lt;Animation animType=&quot;fadeIn&quot; startType=&quot;afterPrevious&quot; duration={600}&gt;&#10;        &lt;Text style={{ fontSize: 16, color: '#CBD5E1', lineHeight: 1.8 }}&gt;· &lt;Text style={{ color: '#34D399', fontWeight: 'bold' }}&gt;落地&lt;/Text&gt;：SiC 功率器件 + 宇航级 SoC 合成「电源-算力合一」主板。&lt;/Text&gt;&#10;      &lt;/Animation&gt;&#10;      &lt;Animation animType=&quot;fadeIn&quot; startType=&quot;afterPrevious&quot; duration={600}&gt;&#10;        &lt;Text style={{ fontSize: 15, color: '#64748B', lineHeight: 1.7 }}&gt;⚠ 仍需：辐照试验 + 飞行认证方可上星。&lt;/Text&gt;&#10;      &lt;/Animation&gt;&#10;    &lt;/Box&gt;&#10;  &lt;/Box&gt;&#10;&lt;/Slide&gt;&#10;"/>
         <p:cNvGrpSpPr/>
         <p:nvPr/>
       </p:nvGrpSpPr>
@@ -13847,7 +13937,7 @@
       </p:grpSpPr>
       <p:sp>
         <p:nvSpPr>
-          <p:cNvPr id="173" name=""/>
+          <p:cNvPr id="174" name=""/>
           <p:cNvSpPr/>
           <p:nvPr/>
         </p:nvSpPr>
@@ -13871,7 +13961,7 @@
       </p:sp>
       <p:sp>
         <p:nvSpPr>
-          <p:cNvPr id="174" name=""/>
+          <p:cNvPr id="175" name=""/>
           <p:cNvSpPr/>
           <p:nvPr/>
         </p:nvSpPr>
@@ -13895,7 +13985,7 @@
       </p:sp>
       <p:sp>
         <p:nvSpPr>
-          <p:cNvPr id="175" name="" descr="{&quot;isTemplate&quot;:true,&quot;type&quot;:&quot;text&quot;}"/>
+          <p:cNvPr id="176" name="" descr="{&quot;isTemplate&quot;:true,&quot;type&quot;:&quot;text&quot;}"/>
           <p:cNvSpPr txBox="1"/>
           <p:nvPr/>
         </p:nvSpPr>
@@ -13948,7 +14038,7 @@
       </p:sp>
       <p:sp>
         <p:nvSpPr>
-          <p:cNvPr id="176" name="" descr="{&quot;isTemplate&quot;:true,&quot;type&quot;:&quot;text&quot;}"/>
+          <p:cNvPr id="177" name="" descr="{&quot;isTemplate&quot;:true,&quot;type&quot;:&quot;text&quot;}"/>
           <p:cNvSpPr txBox="1"/>
           <p:nvPr/>
         </p:nvSpPr>
@@ -14041,7 +14131,7 @@
       </p:sp>
       <p:sp>
         <p:nvSpPr>
-          <p:cNvPr id="177" name="" descr="{&quot;isTemplate&quot;:true,&quot;type&quot;:&quot;text&quot;}"/>
+          <p:cNvPr id="178" name="" descr="{&quot;isTemplate&quot;:true,&quot;type&quot;:&quot;text&quot;}"/>
           <p:cNvSpPr txBox="1"/>
           <p:nvPr/>
         </p:nvSpPr>
@@ -14136,7 +14226,7 @@
       </p:sp>
       <p:sp>
         <p:nvSpPr>
-          <p:cNvPr id="178" name="" descr="{&quot;isTemplate&quot;:true,&quot;type&quot;:&quot;text&quot;}"/>
+          <p:cNvPr id="179" name="" descr="{&quot;isTemplate&quot;:true,&quot;type&quot;:&quot;text&quot;}"/>
           <p:cNvSpPr txBox="1"/>
           <p:nvPr/>
         </p:nvSpPr>
@@ -14251,7 +14341,7 @@
       </p:sp>
       <p:sp>
         <p:nvSpPr>
-          <p:cNvPr id="179" name="" descr="{&quot;isTemplate&quot;:true,&quot;type&quot;:&quot;text&quot;}"/>
+          <p:cNvPr id="180" name="" descr="{&quot;isTemplate&quot;:true,&quot;type&quot;:&quot;text&quot;}"/>
           <p:cNvSpPr txBox="1"/>
           <p:nvPr/>
         </p:nvSpPr>
@@ -14346,7 +14436,7 @@
       </p:sp>
       <p:sp>
         <p:nvSpPr>
-          <p:cNvPr id="180" name="" descr="{&quot;isTemplate&quot;:true,&quot;type&quot;:&quot;text&quot;}"/>
+          <p:cNvPr id="181" name="" descr="{&quot;isTemplate&quot;:true,&quot;type&quot;:&quot;text&quot;}"/>
           <p:cNvSpPr txBox="1"/>
           <p:nvPr/>
         </p:nvSpPr>
@@ -14481,7 +14571,7 @@
       </p:sp>
       <p:sp>
         <p:nvSpPr>
-          <p:cNvPr id="181" name="" descr="{&quot;isTemplate&quot;:true,&quot;type&quot;:&quot;text&quot;}"/>
+          <p:cNvPr id="182" name="" descr="{&quot;isTemplate&quot;:true,&quot;type&quot;:&quot;text&quot;}"/>
           <p:cNvSpPr txBox="1"/>
           <p:nvPr/>
         </p:nvSpPr>
@@ -14567,20 +14657,20 @@
                             </p:stCondLst>
                             <p:childTnLst>
                               <p:par>
-                                <p:cTn id="367" presetID="10" presetClass="entr" presetSubtype="0" fill="hold" grpId="0" nodeType="withEffect">
+                                <p:cTn id="370" presetID="10" presetClass="entr" presetSubtype="0" fill="hold" grpId="0" nodeType="withEffect">
                                   <p:stCondLst>
                                     <p:cond delay="0"/>
                                   </p:stCondLst>
                                   <p:childTnLst>
                                     <p:set>
                                       <p:cBhvr>
-                                        <p:cTn id="368" dur="1" fill="hold">
+                                        <p:cTn id="371" dur="1" fill="hold">
                                           <p:stCondLst>
                                             <p:cond delay="0"/>
                                           </p:stCondLst>
                                         </p:cTn>
                                         <p:tgtEl>
-                                          <p:spTgt spid="177"/>
+                                          <p:spTgt spid="178"/>
                                         </p:tgtEl>
                                         <p:attrNameLst>
                                           <p:attrName>style.visibility</p:attrName>
@@ -14592,9 +14682,9 @@
                                     </p:set>
                                     <p:animEffect transition="in" filter="fade">
                                       <p:cBhvr>
-                                        <p:cTn id="369" dur="600"/>
-                                        <p:tgtEl>
-                                          <p:spTgt spid="177"/>
+                                        <p:cTn id="372" dur="600"/>
+                                        <p:tgtEl>
+                                          <p:spTgt spid="178"/>
                                         </p:tgtEl>
                                       </p:cBhvr>
                                     </p:animEffect>
@@ -14611,20 +14701,20 @@
                             </p:stCondLst>
                             <p:childTnLst>
                               <p:par>
-                                <p:cTn id="370" presetID="10" presetClass="entr" presetSubtype="0" fill="hold" grpId="1" nodeType="afterEffect">
+                                <p:cTn id="373" presetID="10" presetClass="entr" presetSubtype="0" fill="hold" grpId="1" nodeType="afterEffect">
                                   <p:stCondLst>
                                     <p:cond delay="0"/>
                                   </p:stCondLst>
                                   <p:childTnLst>
                                     <p:set>
                                       <p:cBhvr>
-                                        <p:cTn id="371" dur="1" fill="hold">
+                                        <p:cTn id="374" dur="1" fill="hold">
                                           <p:stCondLst>
                                             <p:cond delay="0"/>
                                           </p:stCondLst>
                                         </p:cTn>
                                         <p:tgtEl>
-                                          <p:spTgt spid="178"/>
+                                          <p:spTgt spid="179"/>
                                         </p:tgtEl>
                                         <p:attrNameLst>
                                           <p:attrName>style.visibility</p:attrName>
@@ -14636,9 +14726,9 @@
                                     </p:set>
                                     <p:animEffect transition="in" filter="fade">
                                       <p:cBhvr>
-                                        <p:cTn id="372" dur="600"/>
-                                        <p:tgtEl>
-                                          <p:spTgt spid="178"/>
+                                        <p:cTn id="375" dur="600"/>
+                                        <p:tgtEl>
+                                          <p:spTgt spid="179"/>
                                         </p:tgtEl>
                                       </p:cBhvr>
                                     </p:animEffect>
@@ -14655,20 +14745,20 @@
                             </p:stCondLst>
                             <p:childTnLst>
                               <p:par>
-                                <p:cTn id="373" presetID="10" presetClass="entr" presetSubtype="0" fill="hold" grpId="2" nodeType="afterEffect">
+                                <p:cTn id="376" presetID="10" presetClass="entr" presetSubtype="0" fill="hold" grpId="2" nodeType="afterEffect">
                                   <p:stCondLst>
                                     <p:cond delay="0"/>
                                   </p:stCondLst>
                                   <p:childTnLst>
                                     <p:set>
                                       <p:cBhvr>
-                                        <p:cTn id="374" dur="1" fill="hold">
+                                        <p:cTn id="377" dur="1" fill="hold">
                                           <p:stCondLst>
                                             <p:cond delay="0"/>
                                           </p:stCondLst>
                                         </p:cTn>
                                         <p:tgtEl>
-                                          <p:spTgt spid="179"/>
+                                          <p:spTgt spid="180"/>
                                         </p:tgtEl>
                                         <p:attrNameLst>
                                           <p:attrName>style.visibility</p:attrName>
@@ -14680,9 +14770,9 @@
                                     </p:set>
                                     <p:animEffect transition="in" filter="fade">
                                       <p:cBhvr>
-                                        <p:cTn id="375" dur="600"/>
-                                        <p:tgtEl>
-                                          <p:spTgt spid="179"/>
+                                        <p:cTn id="378" dur="600"/>
+                                        <p:tgtEl>
+                                          <p:spTgt spid="180"/>
                                         </p:tgtEl>
                                       </p:cBhvr>
                                     </p:animEffect>
@@ -14699,20 +14789,20 @@
                             </p:stCondLst>
                             <p:childTnLst>
                               <p:par>
-                                <p:cTn id="376" presetID="10" presetClass="entr" presetSubtype="0" fill="hold" grpId="3" nodeType="afterEffect">
+                                <p:cTn id="379" presetID="10" presetClass="entr" presetSubtype="0" fill="hold" grpId="3" nodeType="afterEffect">
                                   <p:stCondLst>
                                     <p:cond delay="0"/>
                                   </p:stCondLst>
                                   <p:childTnLst>
                                     <p:set>
                                       <p:cBhvr>
-                                        <p:cTn id="377" dur="1" fill="hold">
+                                        <p:cTn id="380" dur="1" fill="hold">
                                           <p:stCondLst>
                                             <p:cond delay="0"/>
                                           </p:stCondLst>
                                         </p:cTn>
                                         <p:tgtEl>
-                                          <p:spTgt spid="180"/>
+                                          <p:spTgt spid="181"/>
                                         </p:tgtEl>
                                         <p:attrNameLst>
                                           <p:attrName>style.visibility</p:attrName>
@@ -14724,9 +14814,9 @@
                                     </p:set>
                                     <p:animEffect transition="in" filter="fade">
                                       <p:cBhvr>
-                                        <p:cTn id="378" dur="600"/>
-                                        <p:tgtEl>
-                                          <p:spTgt spid="180"/>
+                                        <p:cTn id="381" dur="600"/>
+                                        <p:tgtEl>
+                                          <p:spTgt spid="181"/>
                                         </p:tgtEl>
                                       </p:cBhvr>
                                     </p:animEffect>
@@ -14743,20 +14833,20 @@
                             </p:stCondLst>
                             <p:childTnLst>
                               <p:par>
-                                <p:cTn id="379" presetID="10" presetClass="entr" presetSubtype="0" fill="hold" grpId="4" nodeType="afterEffect">
+                                <p:cTn id="382" presetID="10" presetClass="entr" presetSubtype="0" fill="hold" grpId="4" nodeType="afterEffect">
                                   <p:stCondLst>
                                     <p:cond delay="0"/>
                                   </p:stCondLst>
                                   <p:childTnLst>
                                     <p:set>
                                       <p:cBhvr>
-                                        <p:cTn id="380" dur="1" fill="hold">
+                                        <p:cTn id="383" dur="1" fill="hold">
                                           <p:stCondLst>
                                             <p:cond delay="0"/>
                                           </p:stCondLst>
                                         </p:cTn>
                                         <p:tgtEl>
-                                          <p:spTgt spid="181"/>
+                                          <p:spTgt spid="182"/>
                                         </p:tgtEl>
                                         <p:attrNameLst>
                                           <p:attrName>style.visibility</p:attrName>
@@ -14768,9 +14858,9 @@
                                     </p:set>
                                     <p:animEffect transition="in" filter="fade">
                                       <p:cBhvr>
-                                        <p:cTn id="381" dur="600"/>
-                                        <p:tgtEl>
-                                          <p:spTgt spid="181"/>
+                                        <p:cTn id="384" dur="600"/>
+                                        <p:tgtEl>
+                                          <p:spTgt spid="182"/>
                                         </p:tgtEl>
                                       </p:cBhvr>
                                     </p:animEffect>

</xml_diff>